<commit_message>
Clarify the TikTok RPM basis in the research deck
Slide 7 gave TikTok Creator Rewards as 0.40 to 1.00 USD per 1,000 views and
slide 8 gave 160 to 700 USD per million views, which only agree when the RPM
is applied to qualified views (about 40 to 70% of all views). Both slides now
say so. The figures themselves are unchanged. The Facebook row on slide 7 moves
down a little to make room for the longer TikTok label.

Co-Authored-By: Claude Sonnet 5.5 <noreply@anthropic.com>
Claude-Session: https://claude.ai/code/session_018uW6gkgn9CUzNGw4ERV2G7
</commit_message>
<xml_diff>
--- a/research/xu-huong-kiem-tien-youtube-tiktok-facebook.pptx
+++ b/research/xu-huong-kiem-tien-youtube-tiktok-facebook.pptx
@@ -19818,7 +19818,7 @@
         <p:spPr>
           <a:xfrm>
             <a:off x="914400" y="6534150"/>
-            <a:ext cx="4762500" cy="323850"/>
+            <a:ext cx="4762500" cy="609600"/>
           </a:xfrm>
           <a:prstGeom prst="rect">
             <a:avLst/>
@@ -19878,6 +19878,72 @@
               <a:t> USD</a:t>
             </a:r>
             <a:r>
+              <a:rPr lang="en-US" sz="1950" dirty="0" spc="-15" kern="0">
+                <a:solidFill>
+                  <a:srgbClr val="6B6A66"/>
+                </a:solidFill>
+                <a:latin typeface="Be Vietnam Pro" pitchFamily="34" charset="0"/>
+                <a:ea typeface="Be Vietnam Pro" pitchFamily="34" charset="-122"/>
+                <a:cs typeface="Be Vietnam Pro" pitchFamily="34" charset="-120"/>
+              </a:rPr>
+              <a:t> trên</a:t>
+            </a:r>
+            <a:r>
+              <a:rPr lang="en-US" sz="1950" dirty="0" spc="3" kern="0">
+                <a:solidFill>
+                  <a:srgbClr val="6B6A66"/>
+                </a:solidFill>
+                <a:latin typeface="Be Vietnam Pro" pitchFamily="34" charset="0"/>
+                <a:ea typeface="Be Vietnam Pro" pitchFamily="34" charset="-122"/>
+                <a:cs typeface="Be Vietnam Pro" pitchFamily="34" charset="-120"/>
+              </a:rPr>
+              <a:t> lượt</a:t>
+            </a:r>
+            <a:r>
+              <a:rPr lang="en-US" sz="1950" dirty="0" spc="-12" kern="0">
+                <a:solidFill>
+                  <a:srgbClr val="6B6A66"/>
+                </a:solidFill>
+                <a:latin typeface="Be Vietnam Pro" pitchFamily="34" charset="0"/>
+                <a:ea typeface="Be Vietnam Pro" pitchFamily="34" charset="-122"/>
+                <a:cs typeface="Be Vietnam Pro" pitchFamily="34" charset="-120"/>
+              </a:rPr>
+              <a:t> xem</a:t>
+            </a:r>
+            <a:r>
+              <a:rPr lang="en-US" sz="1950" dirty="0" spc="2" kern="0">
+                <a:solidFill>
+                  <a:srgbClr val="6B6A66"/>
+                </a:solidFill>
+                <a:latin typeface="Be Vietnam Pro" pitchFamily="34" charset="0"/>
+                <a:ea typeface="Be Vietnam Pro" pitchFamily="34" charset="-122"/>
+                <a:cs typeface="Be Vietnam Pro" pitchFamily="34" charset="-120"/>
+              </a:rPr>
+              <a:t> đủ</a:t>
+            </a:r>
+            <a:r>
+              <a:rPr lang="en-US" sz="1950" dirty="0" spc="17" kern="0">
+                <a:solidFill>
+                  <a:srgbClr val="6B6A66"/>
+                </a:solidFill>
+                <a:latin typeface="Be Vietnam Pro" pitchFamily="34" charset="0"/>
+                <a:ea typeface="Be Vietnam Pro" pitchFamily="34" charset="-122"/>
+                <a:cs typeface="Be Vietnam Pro" pitchFamily="34" charset="-120"/>
+              </a:rPr>
+              <a:t> điều</a:t>
+            </a:r>
+            <a:r>
+              <a:rPr lang="en-US" sz="1950" dirty="0" spc="0" kern="0">
+                <a:solidFill>
+                  <a:srgbClr val="6B6A66"/>
+                </a:solidFill>
+                <a:latin typeface="Be Vietnam Pro" pitchFamily="34" charset="0"/>
+                <a:ea typeface="Be Vietnam Pro" pitchFamily="34" charset="-122"/>
+                <a:cs typeface="Be Vietnam Pro" pitchFamily="34" charset="-120"/>
+              </a:rPr>
+              <a:t> kiện</a:t>
+            </a:r>
+            <a:r>
               <a:rPr lang="en-US" sz="1950" dirty="0" spc="-2" kern="0">
                 <a:solidFill>
                   <a:srgbClr val="6B6A66"/>
@@ -19886,10 +19952,21 @@
                 <a:ea typeface="Be Vietnam Pro" pitchFamily="34" charset="-122"/>
                 <a:cs typeface="Be Vietnam Pro" pitchFamily="34" charset="-120"/>
               </a:rPr>
-              <a:t> · 8</a:t>
-            </a:r>
-            <a:r>
-              <a:rPr lang="en-US" sz="1950" dirty="0" spc="5" kern="0">
+              <a:t> ·</a:t>
+            </a:r>
+            <a:r>
+              <a:rPr lang="en-US" sz="1950" dirty="0" spc="-1" kern="0">
+                <a:solidFill>
+                  <a:srgbClr val="6B6A66"/>
+                </a:solidFill>
+                <a:latin typeface="Be Vietnam Pro" pitchFamily="34" charset="0"/>
+                <a:ea typeface="Be Vietnam Pro" pitchFamily="34" charset="-122"/>
+                <a:cs typeface="Be Vietnam Pro" pitchFamily="34" charset="-120"/>
+              </a:rPr>
+              <a:t> 8</a:t>
+            </a:r>
+            <a:r>
+              <a:rPr lang="en-US" sz="1950" dirty="0" spc="4" kern="0">
                 <a:solidFill>
                   <a:srgbClr val="6B6A66"/>
                 </a:solidFill>
@@ -19933,7 +20010,7 @@
         </p:nvSpPr>
         <p:spPr>
           <a:xfrm>
-            <a:off x="914400" y="7219950"/>
+            <a:off x="914400" y="7391400"/>
             <a:ext cx="4762500" cy="381000"/>
           </a:xfrm>
           <a:prstGeom prst="rect">
@@ -19983,7 +20060,7 @@
         </p:nvSpPr>
         <p:spPr>
           <a:xfrm>
-            <a:off x="914400" y="7581900"/>
+            <a:off x="914400" y="7753350"/>
             <a:ext cx="4762500" cy="323850"/>
           </a:xfrm>
           <a:prstGeom prst="rect">
@@ -20055,7 +20132,7 @@
         </p:nvSpPr>
         <p:spPr>
           <a:xfrm>
-            <a:off x="6956107" y="7362825"/>
+            <a:off x="6956107" y="7534275"/>
             <a:ext cx="3493770" cy="323850"/>
           </a:xfrm>
           <a:prstGeom prst="roundRect">
@@ -21776,8 +21853,8 @@
         </p:nvSpPr>
         <p:spPr>
           <a:xfrm>
-            <a:off x="914400" y="8743950"/>
-            <a:ext cx="11239500" cy="323850"/>
+            <a:off x="914400" y="8705850"/>
+            <a:ext cx="16459200" cy="609600"/>
           </a:xfrm>
           <a:prstGeom prst="rect">
             <a:avLst/>
@@ -21837,6 +21914,138 @@
               <a:t> trang</a:t>
             </a:r>
             <a:r>
+              <a:rPr lang="en-US" sz="1800" dirty="0" spc="5" kern="0">
+                <a:solidFill>
+                  <a:srgbClr val="9AA0B5"/>
+                </a:solidFill>
+                <a:latin typeface="Be Vietnam Pro" pitchFamily="34" charset="0"/>
+                <a:ea typeface="Be Vietnam Pro" pitchFamily="34" charset="-122"/>
+                <a:cs typeface="Be Vietnam Pro" pitchFamily="34" charset="-120"/>
+              </a:rPr>
+              <a:t> trước.</a:t>
+            </a:r>
+            <a:r>
+              <a:rPr lang="en-US" sz="1800" dirty="0" spc="-21" kern="0">
+                <a:solidFill>
+                  <a:srgbClr val="9AA0B5"/>
+                </a:solidFill>
+                <a:latin typeface="Be Vietnam Pro" pitchFamily="34" charset="0"/>
+                <a:ea typeface="Be Vietnam Pro" pitchFamily="34" charset="-122"/>
+                <a:cs typeface="Be Vietnam Pro" pitchFamily="34" charset="-120"/>
+              </a:rPr>
+              <a:t> Với</a:t>
+            </a:r>
+            <a:r>
+              <a:rPr lang="en-US" sz="1800" dirty="0" spc="-28" kern="0">
+                <a:solidFill>
+                  <a:srgbClr val="9AA0B5"/>
+                </a:solidFill>
+                <a:latin typeface="Be Vietnam Pro" pitchFamily="34" charset="0"/>
+                <a:ea typeface="Be Vietnam Pro" pitchFamily="34" charset="-122"/>
+                <a:cs typeface="Be Vietnam Pro" pitchFamily="34" charset="-120"/>
+              </a:rPr>
+              <a:t> TikTok,</a:t>
+            </a:r>
+            <a:r>
+              <a:rPr lang="en-US" sz="1800" dirty="0" spc="-1" kern="0">
+                <a:solidFill>
+                  <a:srgbClr val="9AA0B5"/>
+                </a:solidFill>
+                <a:latin typeface="Be Vietnam Pro" pitchFamily="34" charset="0"/>
+                <a:ea typeface="Be Vietnam Pro" pitchFamily="34" charset="-122"/>
+                <a:cs typeface="Be Vietnam Pro" pitchFamily="34" charset="-120"/>
+              </a:rPr>
+              <a:t> RPM</a:t>
+            </a:r>
+            <a:r>
+              <a:rPr lang="en-US" sz="1800" dirty="0" spc="0" kern="0">
+                <a:solidFill>
+                  <a:srgbClr val="9AA0B5"/>
+                </a:solidFill>
+                <a:latin typeface="Be Vietnam Pro" pitchFamily="34" charset="0"/>
+                <a:ea typeface="Be Vietnam Pro" pitchFamily="34" charset="-122"/>
+                <a:cs typeface="Be Vietnam Pro" pitchFamily="34" charset="-120"/>
+              </a:rPr>
+              <a:t> áp</a:t>
+            </a:r>
+            <a:r>
+              <a:rPr lang="en-US" sz="1800" dirty="0" spc="-2" kern="0">
+                <a:solidFill>
+                  <a:srgbClr val="9AA0B5"/>
+                </a:solidFill>
+                <a:latin typeface="Be Vietnam Pro" pitchFamily="34" charset="0"/>
+                <a:ea typeface="Be Vietnam Pro" pitchFamily="34" charset="-122"/>
+                <a:cs typeface="Be Vietnam Pro" pitchFamily="34" charset="-120"/>
+              </a:rPr>
+              <a:t> dụng</a:t>
+            </a:r>
+            <a:r>
+              <a:rPr lang="en-US" sz="1800" dirty="0" spc="3" kern="0">
+                <a:solidFill>
+                  <a:srgbClr val="9AA0B5"/>
+                </a:solidFill>
+                <a:latin typeface="Be Vietnam Pro" pitchFamily="34" charset="0"/>
+                <a:ea typeface="Be Vietnam Pro" pitchFamily="34" charset="-122"/>
+                <a:cs typeface="Be Vietnam Pro" pitchFamily="34" charset="-120"/>
+              </a:rPr>
+              <a:t> cho</a:t>
+            </a:r>
+            <a:r>
+              <a:rPr lang="en-US" sz="1800" dirty="0" spc="-2" kern="0">
+                <a:solidFill>
+                  <a:srgbClr val="9AA0B5"/>
+                </a:solidFill>
+                <a:latin typeface="Be Vietnam Pro" pitchFamily="34" charset="0"/>
+                <a:ea typeface="Be Vietnam Pro" pitchFamily="34" charset="-122"/>
+                <a:cs typeface="Be Vietnam Pro" pitchFamily="34" charset="-120"/>
+              </a:rPr>
+              <a:t> khoảng</a:t>
+            </a:r>
+            <a:r>
+              <a:rPr lang="en-US" sz="1800" dirty="0" spc="2" kern="0">
+                <a:solidFill>
+                  <a:srgbClr val="9AA0B5"/>
+                </a:solidFill>
+                <a:latin typeface="Be Vietnam Pro" pitchFamily="34" charset="0"/>
+                <a:ea typeface="Be Vietnam Pro" pitchFamily="34" charset="-122"/>
+                <a:cs typeface="Be Vietnam Pro" pitchFamily="34" charset="-120"/>
+              </a:rPr>
+              <a:t> 40</a:t>
+            </a:r>
+            <a:r>
+              <a:rPr lang="en-US" sz="1800" dirty="0" spc="8" kern="0">
+                <a:solidFill>
+                  <a:srgbClr val="9AA0B5"/>
+                </a:solidFill>
+                <a:latin typeface="Be Vietnam Pro" pitchFamily="34" charset="0"/>
+                <a:ea typeface="Be Vietnam Pro" pitchFamily="34" charset="-122"/>
+                <a:cs typeface="Be Vietnam Pro" pitchFamily="34" charset="-120"/>
+              </a:rPr>
+              <a:t> đến</a:t>
+            </a:r>
+            <a:r>
+              <a:rPr lang="en-US" sz="1800" dirty="0" spc="-21" kern="0">
+                <a:solidFill>
+                  <a:srgbClr val="9AA0B5"/>
+                </a:solidFill>
+                <a:latin typeface="Be Vietnam Pro" pitchFamily="34" charset="0"/>
+                <a:ea typeface="Be Vietnam Pro" pitchFamily="34" charset="-122"/>
+                <a:cs typeface="Be Vietnam Pro" pitchFamily="34" charset="-120"/>
+              </a:rPr>
+              <a:t> 70%</a:t>
+            </a:r>
+            <a:r>
+              <a:rPr lang="en-US" sz="1800" dirty="0" spc="-11" kern="0">
+                <a:solidFill>
+                  <a:srgbClr val="9AA0B5"/>
+                </a:solidFill>
+                <a:latin typeface="Be Vietnam Pro" pitchFamily="34" charset="0"/>
+                <a:ea typeface="Be Vietnam Pro" pitchFamily="34" charset="-122"/>
+                <a:cs typeface="Be Vietnam Pro" pitchFamily="34" charset="-120"/>
+              </a:rPr>
+              <a:t> tổng</a:t>
+            </a:r>
+            <a:r>
               <a:rPr lang="en-US" sz="1800" dirty="0" spc="4" kern="0">
                 <a:solidFill>
                   <a:srgbClr val="9AA0B5"/>
@@ -21845,10 +22054,10 @@
                 <a:ea typeface="Be Vietnam Pro" pitchFamily="34" charset="-122"/>
                 <a:cs typeface="Be Vietnam Pro" pitchFamily="34" charset="-120"/>
               </a:rPr>
-              <a:t> trước;</a:t>
-            </a:r>
-            <a:r>
-              <a:rPr lang="en-US" sz="1800" dirty="0" spc="-32" kern="0">
+              <a:t> lượt</a:t>
+            </a:r>
+            <a:r>
+              <a:rPr lang="en-US" sz="1800" dirty="0" spc="-12" kern="0">
                 <a:solidFill>
                   <a:srgbClr val="9AA0B5"/>
                 </a:solidFill>
@@ -21856,10 +22065,10 @@
                 <a:ea typeface="Be Vietnam Pro" pitchFamily="34" charset="-122"/>
                 <a:cs typeface="Be Vietnam Pro" pitchFamily="34" charset="-120"/>
               </a:rPr>
-              <a:t> TikTok</a:t>
-            </a:r>
-            <a:r>
-              <a:rPr lang="en-US" sz="1800" dirty="0" spc="8" kern="0">
+              <a:t> xem</a:t>
+            </a:r>
+            <a:r>
+              <a:rPr lang="en-US" sz="1800" dirty="0" spc="3" kern="0">
                 <a:solidFill>
                   <a:srgbClr val="9AA0B5"/>
                 </a:solidFill>
@@ -21867,6 +22076,61 @@
                 <a:ea typeface="Be Vietnam Pro" pitchFamily="34" charset="-122"/>
                 <a:cs typeface="Be Vietnam Pro" pitchFamily="34" charset="-120"/>
               </a:rPr>
+              <a:t> (lượt</a:t>
+            </a:r>
+            <a:r>
+              <a:rPr lang="en-US" sz="1800" dirty="0" spc="-11" kern="0">
+                <a:solidFill>
+                  <a:srgbClr val="9AA0B5"/>
+                </a:solidFill>
+                <a:latin typeface="Be Vietnam Pro" pitchFamily="34" charset="0"/>
+                <a:ea typeface="Be Vietnam Pro" pitchFamily="34" charset="-122"/>
+                <a:cs typeface="Be Vietnam Pro" pitchFamily="34" charset="-120"/>
+              </a:rPr>
+              <a:t> xem</a:t>
+            </a:r>
+            <a:r>
+              <a:rPr lang="en-US" sz="1800" dirty="0" spc="2" kern="0">
+                <a:solidFill>
+                  <a:srgbClr val="9AA0B5"/>
+                </a:solidFill>
+                <a:latin typeface="Be Vietnam Pro" pitchFamily="34" charset="0"/>
+                <a:ea typeface="Be Vietnam Pro" pitchFamily="34" charset="-122"/>
+                <a:cs typeface="Be Vietnam Pro" pitchFamily="34" charset="-120"/>
+              </a:rPr>
+              <a:t> đủ</a:t>
+            </a:r>
+            <a:r>
+              <a:rPr lang="en-US" sz="1800" dirty="0" spc="13" kern="0">
+                <a:solidFill>
+                  <a:srgbClr val="9AA0B5"/>
+                </a:solidFill>
+                <a:latin typeface="Be Vietnam Pro" pitchFamily="34" charset="0"/>
+                <a:ea typeface="Be Vietnam Pro" pitchFamily="34" charset="-122"/>
+                <a:cs typeface="Be Vietnam Pro" pitchFamily="34" charset="-120"/>
+              </a:rPr>
+              <a:t> điều</a:t>
+            </a:r>
+            <a:r>
+              <a:rPr lang="en-US" sz="1800" dirty="0" spc="-1" kern="0">
+                <a:solidFill>
+                  <a:srgbClr val="9AA0B5"/>
+                </a:solidFill>
+                <a:latin typeface="Be Vietnam Pro" pitchFamily="34" charset="0"/>
+                <a:ea typeface="Be Vietnam Pro" pitchFamily="34" charset="-122"/>
+                <a:cs typeface="Be Vietnam Pro" pitchFamily="34" charset="-120"/>
+              </a:rPr>
+              <a:t> kiện);</a:t>
+            </a:r>
+            <a:r>
+              <a:rPr lang="en-US" sz="1800" dirty="0" spc="7" kern="0">
+                <a:solidFill>
+                  <a:srgbClr val="9AA0B5"/>
+                </a:solidFill>
+                <a:latin typeface="Be Vietnam Pro" pitchFamily="34" charset="0"/>
+                <a:ea typeface="Be Vietnam Pro" pitchFamily="34" charset="-122"/>
+                <a:cs typeface="Be Vietnam Pro" pitchFamily="34" charset="-120"/>
+              </a:rPr>
               <a:t> chưa</a:t>
             </a:r>
             <a:r>
@@ -21878,10 +22142,21 @@
                 <a:ea typeface="Be Vietnam Pro" pitchFamily="34" charset="-122"/>
                 <a:cs typeface="Be Vietnam Pro" pitchFamily="34" charset="-120"/>
               </a:rPr>
-              <a:t> tính Additional</a:t>
-            </a:r>
-            <a:r>
-              <a:rPr lang="en-US" sz="1800" dirty="0" spc="-27" kern="0">
+              <a:t> tính</a:t>
+            </a:r>
+            <a:r>
+              <a:rPr lang="en-US" sz="1800" dirty="0" spc="-4" kern="0">
+                <a:solidFill>
+                  <a:srgbClr val="9AA0B5"/>
+                </a:solidFill>
+                <a:latin typeface="Be Vietnam Pro" pitchFamily="34" charset="0"/>
+                <a:ea typeface="Be Vietnam Pro" pitchFamily="34" charset="-122"/>
+                <a:cs typeface="Be Vietnam Pro" pitchFamily="34" charset="-120"/>
+              </a:rPr>
+              <a:t> Additional</a:t>
+            </a:r>
+            <a:r>
+              <a:rPr lang="en-US" sz="1800" dirty="0" spc="-26" kern="0">
                 <a:solidFill>
                   <a:srgbClr val="9AA0B5"/>
                 </a:solidFill>

</xml_diff>

<commit_message>
Commit the source report behind the research deck and point the deck at it
The deck's cover promised confidence labels and full sources "in the full
report", but that report was not in the repository, so the third-party RPM
ranges and the qualified-view percentage could not be traced from a checkout.
Add the report (every figure tagged official, high, medium or low confidence,
with its sources and the points still to verify), list it in research/README.md,
and name it on slide 1 and slide 12 of the deck. The re-exported PPTX keeps
Moda's free-plan moda.app badge.

Co-Authored-By: Claude Sonnet 5.5 <noreply@anthropic.com>
Claude-Session: https://claude.ai/code/session_018uW6gkgn9CUzNGw4ERV2G7
</commit_message>
<xml_diff>
--- a/research/xu-huong-kiem-tien-youtube-tiktok-facebook.pptx
+++ b/research/xu-huong-kiem-tien-youtube-tiktok-facebook.pptx
@@ -2387,7 +2387,7 @@
         <p:spPr>
           <a:xfrm>
             <a:off x="914400" y="9715500"/>
-            <a:ext cx="9525000" cy="285750"/>
+            <a:ext cx="16459200" cy="285750"/>
           </a:xfrm>
           <a:prstGeom prst="rect">
             <a:avLst/>
@@ -2403,6 +2403,116 @@
               <a:buNone/>
             </a:pPr>
             <a:r>
+              <a:rPr lang="en-US" sz="1650" dirty="0" spc="0" kern="0">
+                <a:solidFill>
+                  <a:srgbClr val="9AA0B5"/>
+                </a:solidFill>
+                <a:latin typeface="Be Vietnam Pro" pitchFamily="34" charset="0"/>
+                <a:ea typeface="Be Vietnam Pro" pitchFamily="34" charset="-122"/>
+                <a:cs typeface="Be Vietnam Pro" pitchFamily="34" charset="-120"/>
+              </a:rPr>
+              <a:t>Báo cáo</a:t>
+            </a:r>
+            <a:r>
+              <a:rPr lang="en-US" sz="1650" dirty="0" spc="5" kern="0">
+                <a:solidFill>
+                  <a:srgbClr val="9AA0B5"/>
+                </a:solidFill>
+                <a:latin typeface="Be Vietnam Pro" pitchFamily="34" charset="0"/>
+                <a:ea typeface="Be Vietnam Pro" pitchFamily="34" charset="-122"/>
+                <a:cs typeface="Be Vietnam Pro" pitchFamily="34" charset="-120"/>
+              </a:rPr>
+              <a:t> đầy</a:t>
+            </a:r>
+            <a:r>
+              <a:rPr lang="en-US" sz="1650" dirty="0" spc="3" kern="0">
+                <a:solidFill>
+                  <a:srgbClr val="9AA0B5"/>
+                </a:solidFill>
+                <a:latin typeface="Be Vietnam Pro" pitchFamily="34" charset="0"/>
+                <a:ea typeface="Be Vietnam Pro" pitchFamily="34" charset="-122"/>
+                <a:cs typeface="Be Vietnam Pro" pitchFamily="34" charset="-120"/>
+              </a:rPr>
+              <a:t> đủ,</a:t>
+            </a:r>
+            <a:r>
+              <a:rPr lang="en-US" sz="1650" dirty="0" spc="-2" kern="0">
+                <a:solidFill>
+                  <a:srgbClr val="9AA0B5"/>
+                </a:solidFill>
+                <a:latin typeface="Be Vietnam Pro" pitchFamily="34" charset="0"/>
+                <a:ea typeface="Be Vietnam Pro" pitchFamily="34" charset="-122"/>
+                <a:cs typeface="Be Vietnam Pro" pitchFamily="34" charset="-120"/>
+              </a:rPr>
+              <a:t> nguồn</a:t>
+            </a:r>
+            <a:r>
+              <a:rPr lang="en-US" sz="1650" dirty="0" spc="-8" kern="0">
+                <a:solidFill>
+                  <a:srgbClr val="9AA0B5"/>
+                </a:solidFill>
+                <a:latin typeface="Be Vietnam Pro" pitchFamily="34" charset="0"/>
+                <a:ea typeface="Be Vietnam Pro" pitchFamily="34" charset="-122"/>
+                <a:cs typeface="Be Vietnam Pro" pitchFamily="34" charset="-120"/>
+              </a:rPr>
+              <a:t> và</a:t>
+            </a:r>
+            <a:r>
+              <a:rPr lang="en-US" sz="1650" dirty="0" spc="14" kern="0">
+                <a:solidFill>
+                  <a:srgbClr val="9AA0B5"/>
+                </a:solidFill>
+                <a:latin typeface="Be Vietnam Pro" pitchFamily="34" charset="0"/>
+                <a:ea typeface="Be Vietnam Pro" pitchFamily="34" charset="-122"/>
+                <a:cs typeface="Be Vietnam Pro" pitchFamily="34" charset="-120"/>
+              </a:rPr>
+              <a:t> độ</a:t>
+            </a:r>
+            <a:r>
+              <a:rPr lang="en-US" sz="1650" dirty="0" spc="1" kern="0">
+                <a:solidFill>
+                  <a:srgbClr val="9AA0B5"/>
+                </a:solidFill>
+                <a:latin typeface="Be Vietnam Pro" pitchFamily="34" charset="0"/>
+                <a:ea typeface="Be Vietnam Pro" pitchFamily="34" charset="-122"/>
+                <a:cs typeface="Be Vietnam Pro" pitchFamily="34" charset="-120"/>
+              </a:rPr>
+              <a:t> tin</a:t>
+            </a:r>
+            <a:r>
+              <a:rPr lang="en-US" sz="1650" dirty="0" spc="-5" kern="0">
+                <a:solidFill>
+                  <a:srgbClr val="9AA0B5"/>
+                </a:solidFill>
+                <a:latin typeface="Be Vietnam Pro" pitchFamily="34" charset="0"/>
+                <a:ea typeface="Be Vietnam Pro" pitchFamily="34" charset="-122"/>
+                <a:cs typeface="Be Vietnam Pro" pitchFamily="34" charset="-120"/>
+              </a:rPr>
+              <a:t> cậy</a:t>
+            </a:r>
+            <a:r>
+              <a:rPr lang="en-US" sz="1650" dirty="0" spc="15" kern="0">
+                <a:solidFill>
+                  <a:srgbClr val="9AA0B5"/>
+                </a:solidFill>
+                <a:latin typeface="Be Vietnam Pro" pitchFamily="34" charset="0"/>
+                <a:ea typeface="Be Vietnam Pro" pitchFamily="34" charset="-122"/>
+                <a:cs typeface="Be Vietnam Pro" pitchFamily="34" charset="-120"/>
+              </a:rPr>
+              <a:t> từng</a:t>
+            </a:r>
+            <a:r>
+              <a:rPr lang="en-US" sz="1650" dirty="0" spc="-4" kern="0">
+                <a:solidFill>
+                  <a:srgbClr val="9AA0B5"/>
+                </a:solidFill>
+                <a:latin typeface="Be Vietnam Pro" pitchFamily="34" charset="0"/>
+                <a:ea typeface="Be Vietnam Pro" pitchFamily="34" charset="-122"/>
+                <a:cs typeface="Be Vietnam Pro" pitchFamily="34" charset="-120"/>
+              </a:rPr>
+              <a:t> số</a:t>
+            </a:r>
+            <a:r>
               <a:rPr lang="en-US" sz="1650" dirty="0" spc="-1" kern="0">
                 <a:solidFill>
                   <a:srgbClr val="9AA0B5"/>
@@ -2411,10 +2521,10 @@
                 <a:ea typeface="Be Vietnam Pro" pitchFamily="34" charset="-122"/>
                 <a:cs typeface="Be Vietnam Pro" pitchFamily="34" charset="-120"/>
               </a:rPr>
-              <a:t>Bản</a:t>
-            </a:r>
-            <a:r>
-              <a:rPr lang="en-US" sz="1650" dirty="0" spc="3" kern="0">
+              <a:t> liệu:</a:t>
+            </a:r>
+            <a:r>
+              <a:rPr lang="en-US" sz="1650" dirty="0" spc="-6" kern="0">
                 <a:solidFill>
                   <a:srgbClr val="9AA0B5"/>
                 </a:solidFill>
@@ -2422,150 +2532,7 @@
                 <a:ea typeface="Be Vietnam Pro" pitchFamily="34" charset="-122"/>
                 <a:cs typeface="Be Vietnam Pro" pitchFamily="34" charset="-120"/>
               </a:rPr>
-              <a:t> 3</a:t>
-            </a:r>
-            <a:r>
-              <a:rPr lang="en-US" sz="1650" dirty="0" spc="0" kern="0">
-                <a:solidFill>
-                  <a:srgbClr val="9AA0B5"/>
-                </a:solidFill>
-                <a:latin typeface="Be Vietnam Pro" pitchFamily="34" charset="0"/>
-                <a:ea typeface="Be Vietnam Pro" pitchFamily="34" charset="-122"/>
-                <a:cs typeface="Be Vietnam Pro" pitchFamily="34" charset="-120"/>
-              </a:rPr>
-              <a:t> ·</a:t>
-            </a:r>
-            <a:r>
-              <a:rPr lang="en-US" sz="1650" dirty="0" spc="1" kern="0">
-                <a:solidFill>
-                  <a:srgbClr val="9AA0B5"/>
-                </a:solidFill>
-                <a:latin typeface="Be Vietnam Pro" pitchFamily="34" charset="0"/>
-                <a:ea typeface="Be Vietnam Pro" pitchFamily="34" charset="-122"/>
-                <a:cs typeface="Be Vietnam Pro" pitchFamily="34" charset="-120"/>
-              </a:rPr>
-              <a:t> mỗi</a:t>
-            </a:r>
-            <a:r>
-              <a:rPr lang="en-US" sz="1650" dirty="0" spc="-4" kern="0">
-                <a:solidFill>
-                  <a:srgbClr val="9AA0B5"/>
-                </a:solidFill>
-                <a:latin typeface="Be Vietnam Pro" pitchFamily="34" charset="0"/>
-                <a:ea typeface="Be Vietnam Pro" pitchFamily="34" charset="-122"/>
-                <a:cs typeface="Be Vietnam Pro" pitchFamily="34" charset="-120"/>
-              </a:rPr>
-              <a:t> số</a:t>
-            </a:r>
-            <a:r>
-              <a:rPr lang="en-US" sz="1650" dirty="0" spc="0" kern="0">
-                <a:solidFill>
-                  <a:srgbClr val="9AA0B5"/>
-                </a:solidFill>
-                <a:latin typeface="Be Vietnam Pro" pitchFamily="34" charset="0"/>
-                <a:ea typeface="Be Vietnam Pro" pitchFamily="34" charset="-122"/>
-                <a:cs typeface="Be Vietnam Pro" pitchFamily="34" charset="-120"/>
-              </a:rPr>
-              <a:t> liệu</a:t>
-            </a:r>
-            <a:r>
-              <a:rPr lang="en-US" sz="1650" dirty="0" spc="-8" kern="0">
-                <a:solidFill>
-                  <a:srgbClr val="9AA0B5"/>
-                </a:solidFill>
-                <a:latin typeface="Be Vietnam Pro" pitchFamily="34" charset="0"/>
-                <a:ea typeface="Be Vietnam Pro" pitchFamily="34" charset="-122"/>
-                <a:cs typeface="Be Vietnam Pro" pitchFamily="34" charset="-120"/>
-              </a:rPr>
-              <a:t> gắn</a:t>
-            </a:r>
-            <a:r>
-              <a:rPr lang="en-US" sz="1650" dirty="0" spc="14" kern="0">
-                <a:solidFill>
-                  <a:srgbClr val="9AA0B5"/>
-                </a:solidFill>
-                <a:latin typeface="Be Vietnam Pro" pitchFamily="34" charset="0"/>
-                <a:ea typeface="Be Vietnam Pro" pitchFamily="34" charset="-122"/>
-                <a:cs typeface="Be Vietnam Pro" pitchFamily="34" charset="-120"/>
-              </a:rPr>
-              <a:t> độ</a:t>
-            </a:r>
-            <a:r>
-              <a:rPr lang="en-US" sz="1650" dirty="0" spc="1" kern="0">
-                <a:solidFill>
-                  <a:srgbClr val="9AA0B5"/>
-                </a:solidFill>
-                <a:latin typeface="Be Vietnam Pro" pitchFamily="34" charset="0"/>
-                <a:ea typeface="Be Vietnam Pro" pitchFamily="34" charset="-122"/>
-                <a:cs typeface="Be Vietnam Pro" pitchFamily="34" charset="-120"/>
-              </a:rPr>
-              <a:t> tin</a:t>
-            </a:r>
-            <a:r>
-              <a:rPr lang="en-US" sz="1650" dirty="0" spc="-5" kern="0">
-                <a:solidFill>
-                  <a:srgbClr val="9AA0B5"/>
-                </a:solidFill>
-                <a:latin typeface="Be Vietnam Pro" pitchFamily="34" charset="0"/>
-                <a:ea typeface="Be Vietnam Pro" pitchFamily="34" charset="-122"/>
-                <a:cs typeface="Be Vietnam Pro" pitchFamily="34" charset="-120"/>
-              </a:rPr>
-              <a:t> cậy</a:t>
-            </a:r>
-            <a:r>
-              <a:rPr lang="en-US" sz="1650" dirty="0" spc="-11" kern="0">
-                <a:solidFill>
-                  <a:srgbClr val="9AA0B5"/>
-                </a:solidFill>
-                <a:latin typeface="Be Vietnam Pro" pitchFamily="34" charset="0"/>
-                <a:ea typeface="Be Vietnam Pro" pitchFamily="34" charset="-122"/>
-                <a:cs typeface="Be Vietnam Pro" pitchFamily="34" charset="-120"/>
-              </a:rPr>
-              <a:t> trong</a:t>
-            </a:r>
-            <a:r>
-              <a:rPr lang="en-US" sz="1650" dirty="0" spc="-1" kern="0">
-                <a:solidFill>
-                  <a:srgbClr val="9AA0B5"/>
-                </a:solidFill>
-                <a:latin typeface="Be Vietnam Pro" pitchFamily="34" charset="0"/>
-                <a:ea typeface="Be Vietnam Pro" pitchFamily="34" charset="-122"/>
-                <a:cs typeface="Be Vietnam Pro" pitchFamily="34" charset="-120"/>
-              </a:rPr>
-              <a:t> báo</a:t>
-            </a:r>
-            <a:r>
-              <a:rPr lang="en-US" sz="1650" dirty="0" spc="1" kern="0">
-                <a:solidFill>
-                  <a:srgbClr val="9AA0B5"/>
-                </a:solidFill>
-                <a:latin typeface="Be Vietnam Pro" pitchFamily="34" charset="0"/>
-                <a:ea typeface="Be Vietnam Pro" pitchFamily="34" charset="-122"/>
-                <a:cs typeface="Be Vietnam Pro" pitchFamily="34" charset="-120"/>
-              </a:rPr>
-              <a:t> cáo</a:t>
-            </a:r>
-            <a:r>
-              <a:rPr lang="en-US" sz="1650" dirty="0" spc="5" kern="0">
-                <a:solidFill>
-                  <a:srgbClr val="9AA0B5"/>
-                </a:solidFill>
-                <a:latin typeface="Be Vietnam Pro" pitchFamily="34" charset="0"/>
-                <a:ea typeface="Be Vietnam Pro" pitchFamily="34" charset="-122"/>
-                <a:cs typeface="Be Vietnam Pro" pitchFamily="34" charset="-120"/>
-              </a:rPr>
-              <a:t> đầy</a:t>
-            </a:r>
-            <a:r>
-              <a:rPr lang="en-US" sz="1650" dirty="0" spc="3" kern="0">
-                <a:solidFill>
-                  <a:srgbClr val="9AA0B5"/>
-                </a:solidFill>
-                <a:latin typeface="Be Vietnam Pro" pitchFamily="34" charset="0"/>
-                <a:ea typeface="Be Vietnam Pro" pitchFamily="34" charset="-122"/>
-                <a:cs typeface="Be Vietnam Pro" pitchFamily="34" charset="-120"/>
-              </a:rPr>
-              <a:t> đủ</a:t>
+              <a:t> research/xu-huong-kiem-tien-youtube-tiktok-facebook.md</a:t>
             </a:r>
             <a:endParaRPr lang="en-US" sz="1650" dirty="0"/>
           </a:p>
@@ -8198,6 +8165,61 @@
                 <a:cs typeface="Be Vietnam Pro" pitchFamily="34" charset="-120"/>
               </a:rPr>
               <a:t> THỨC</a:t>
+            </a:r>
+            <a:r>
+              <a:rPr lang="en-US" sz="1650" b="1" spc="230" kern="0" dirty="0">
+                <a:solidFill>
+                  <a:srgbClr val="F3EEE3"/>
+                </a:solidFill>
+                <a:latin typeface="Be Vietnam Pro" pitchFamily="34" charset="0"/>
+                <a:ea typeface="Be Vietnam Pro" pitchFamily="34" charset="-122"/>
+                <a:cs typeface="Be Vietnam Pro" pitchFamily="34" charset="-120"/>
+              </a:rPr>
+              <a:t> ·</a:t>
+            </a:r>
+            <a:r>
+              <a:rPr lang="en-US" sz="1650" b="1" spc="226" kern="0" dirty="0">
+                <a:solidFill>
+                  <a:srgbClr val="F3EEE3"/>
+                </a:solidFill>
+                <a:latin typeface="Be Vietnam Pro" pitchFamily="34" charset="0"/>
+                <a:ea typeface="Be Vietnam Pro" pitchFamily="34" charset="-122"/>
+                <a:cs typeface="Be Vietnam Pro" pitchFamily="34" charset="-120"/>
+              </a:rPr>
+              <a:t> CHI</a:t>
+            </a:r>
+            <a:r>
+              <a:rPr lang="en-US" sz="1650" b="1" spc="225" kern="0" dirty="0">
+                <a:solidFill>
+                  <a:srgbClr val="F3EEE3"/>
+                </a:solidFill>
+                <a:latin typeface="Be Vietnam Pro" pitchFamily="34" charset="0"/>
+                <a:ea typeface="Be Vietnam Pro" pitchFamily="34" charset="-122"/>
+                <a:cs typeface="Be Vietnam Pro" pitchFamily="34" charset="-120"/>
+              </a:rPr>
+              <a:t> TIẾT</a:t>
+            </a:r>
+            <a:r>
+              <a:rPr lang="en-US" sz="1650" b="1" spc="217" kern="0" dirty="0">
+                <a:solidFill>
+                  <a:srgbClr val="F3EEE3"/>
+                </a:solidFill>
+                <a:latin typeface="Be Vietnam Pro" pitchFamily="34" charset="0"/>
+                <a:ea typeface="Be Vietnam Pro" pitchFamily="34" charset="-122"/>
+                <a:cs typeface="Be Vietnam Pro" pitchFamily="34" charset="-120"/>
+              </a:rPr>
+              <a:t> TRONG</a:t>
+            </a:r>
+            <a:r>
+              <a:rPr lang="en-US" sz="1650" b="1" spc="219" kern="0" dirty="0">
+                <a:solidFill>
+                  <a:srgbClr val="F3EEE3"/>
+                </a:solidFill>
+                <a:latin typeface="Be Vietnam Pro" pitchFamily="34" charset="0"/>
+                <a:ea typeface="Be Vietnam Pro" pitchFamily="34" charset="-122"/>
+                <a:cs typeface="Be Vietnam Pro" pitchFamily="34" charset="-120"/>
+              </a:rPr>
+              <a:t> research/xu-huong-kiem-tien-youtube-tiktok-facebook.md</a:t>
             </a:r>
             <a:endParaRPr lang="en-US" sz="1650" dirty="0"/>
           </a:p>

</xml_diff>

<commit_message>
Present the TikTok one-million-view estimate for qualified views only
The report and slide 8 turned one million views into 400,000-700,000 qualified
views, a 40-70% share that no source in the report supports; TikTok defines
qualified views by exclusions and publishes no share. Show the estimate for one
million qualified views (400-1,000 USD) and say the real figure is lower when
only part of the views qualify. The deck is re-exported from Moda, so the
free-plan moda.app badge stays on every slide.

Co-Authored-By: Claude Sonnet 5.5 <noreply@anthropic.com>
Claude-Session: https://claude.ai/code/session_018uW6gkgn9CUzNGw4ERV2G7
</commit_message>
<xml_diff>
--- a/research/xu-huong-kiem-tien-youtube-tiktok-facebook.pptx
+++ b/research/xu-huong-kiem-tien-youtube-tiktok-facebook.pptx
@@ -21673,7 +21673,7 @@
               <a:buNone/>
             </a:pPr>
             <a:r>
-              <a:rPr lang="en-US" sz="3450" dirty="0" spc="-3" kern="0">
+              <a:rPr lang="en-US" sz="3450" dirty="0" spc="-5" kern="0">
                 <a:solidFill>
                   <a:srgbClr val="3DD6A0"/>
                 </a:solidFill>
@@ -21681,7 +21681,7 @@
                 <a:ea typeface="Bricolage Grotesque ExtraBold" pitchFamily="34" charset="-122"/>
                 <a:cs typeface="Bricolage Grotesque ExtraBold" pitchFamily="34" charset="-120"/>
               </a:rPr>
-              <a:t>160</a:t>
+              <a:t>400</a:t>
             </a:r>
             <a:r>
               <a:rPr lang="en-US" sz="3450" dirty="0" spc="9" kern="0">
@@ -21695,7 +21695,7 @@
               <a:t> đến</a:t>
             </a:r>
             <a:r>
-              <a:rPr lang="en-US" sz="3450" dirty="0" spc="-13" kern="0">
+              <a:rPr lang="en-US" sz="3450" dirty="0" spc="-12" kern="0">
                 <a:solidFill>
                   <a:srgbClr val="3DD6A0"/>
                 </a:solidFill>
@@ -21703,7 +21703,7 @@
                 <a:ea typeface="Bricolage Grotesque ExtraBold" pitchFamily="34" charset="-122"/>
                 <a:cs typeface="Bricolage Grotesque ExtraBold" pitchFamily="34" charset="-120"/>
               </a:rPr>
-              <a:t> 700</a:t>
+              <a:t> 1.000</a:t>
             </a:r>
             <a:r>
               <a:rPr lang="en-US" sz="3450" dirty="0" spc="3" kern="0">
@@ -21947,7 +21947,7 @@
               <a:t> trước.</a:t>
             </a:r>
             <a:r>
-              <a:rPr lang="en-US" sz="1800" dirty="0" spc="-21" kern="0">
+              <a:rPr lang="en-US" sz="1800" dirty="0" spc="-27" kern="0">
                 <a:solidFill>
                   <a:srgbClr val="9AA0B5"/>
                 </a:solidFill>
@@ -21955,10 +21955,10 @@
                 <a:ea typeface="Be Vietnam Pro" pitchFamily="34" charset="-122"/>
                 <a:cs typeface="Be Vietnam Pro" pitchFamily="34" charset="-120"/>
               </a:rPr>
-              <a:t> Với</a:t>
-            </a:r>
-            <a:r>
-              <a:rPr lang="en-US" sz="1800" dirty="0" spc="-28" kern="0">
+              <a:t> TikTok:</a:t>
+            </a:r>
+            <a:r>
+              <a:rPr lang="en-US" sz="1800" dirty="0" spc="-3" kern="0">
                 <a:solidFill>
                   <a:srgbClr val="9AA0B5"/>
                 </a:solidFill>
@@ -21966,7 +21966,293 @@
                 <a:ea typeface="Be Vietnam Pro" pitchFamily="34" charset="-122"/>
                 <a:cs typeface="Be Vietnam Pro" pitchFamily="34" charset="-120"/>
               </a:rPr>
-              <a:t> TikTok,</a:t>
+              <a:t> tính</a:t>
+            </a:r>
+            <a:r>
+              <a:rPr lang="en-US" sz="1800" dirty="0" spc="2" kern="0">
+                <a:solidFill>
+                  <a:srgbClr val="9AA0B5"/>
+                </a:solidFill>
+                <a:latin typeface="Be Vietnam Pro" pitchFamily="34" charset="0"/>
+                <a:ea typeface="Be Vietnam Pro" pitchFamily="34" charset="-122"/>
+                <a:cs typeface="Be Vietnam Pro" pitchFamily="34" charset="-120"/>
+              </a:rPr>
+              <a:t> cho</a:t>
+            </a:r>
+            <a:r>
+              <a:rPr lang="en-US" sz="1800" dirty="0" spc="4" kern="0">
+                <a:solidFill>
+                  <a:srgbClr val="9AA0B5"/>
+                </a:solidFill>
+                <a:latin typeface="Be Vietnam Pro" pitchFamily="34" charset="0"/>
+                <a:ea typeface="Be Vietnam Pro" pitchFamily="34" charset="-122"/>
+                <a:cs typeface="Be Vietnam Pro" pitchFamily="34" charset="-120"/>
+              </a:rPr>
+              <a:t> 1</a:t>
+            </a:r>
+            <a:r>
+              <a:rPr lang="en-US" sz="1800" dirty="0" spc="5" kern="0">
+                <a:solidFill>
+                  <a:srgbClr val="9AA0B5"/>
+                </a:solidFill>
+                <a:latin typeface="Be Vietnam Pro" pitchFamily="34" charset="0"/>
+                <a:ea typeface="Be Vietnam Pro" pitchFamily="34" charset="-122"/>
+                <a:cs typeface="Be Vietnam Pro" pitchFamily="34" charset="-120"/>
+              </a:rPr>
+              <a:t> triệu</a:t>
+            </a:r>
+            <a:r>
+              <a:rPr lang="en-US" sz="1800" dirty="0" spc="4" kern="0">
+                <a:solidFill>
+                  <a:srgbClr val="9AA0B5"/>
+                </a:solidFill>
+                <a:latin typeface="Be Vietnam Pro" pitchFamily="34" charset="0"/>
+                <a:ea typeface="Be Vietnam Pro" pitchFamily="34" charset="-122"/>
+                <a:cs typeface="Be Vietnam Pro" pitchFamily="34" charset="-120"/>
+              </a:rPr>
+              <a:t> lượt</a:t>
+            </a:r>
+            <a:r>
+              <a:rPr lang="en-US" sz="1800" dirty="0" spc="-13" kern="0">
+                <a:solidFill>
+                  <a:srgbClr val="9AA0B5"/>
+                </a:solidFill>
+                <a:latin typeface="Be Vietnam Pro" pitchFamily="34" charset="0"/>
+                <a:ea typeface="Be Vietnam Pro" pitchFamily="34" charset="-122"/>
+                <a:cs typeface="Be Vietnam Pro" pitchFamily="34" charset="-120"/>
+              </a:rPr>
+              <a:t> xem</a:t>
+            </a:r>
+            <a:r>
+              <a:rPr lang="en-US" sz="1800" dirty="0" spc="3" kern="0">
+                <a:solidFill>
+                  <a:srgbClr val="9AA0B5"/>
+                </a:solidFill>
+                <a:latin typeface="Be Vietnam Pro" pitchFamily="34" charset="0"/>
+                <a:ea typeface="Be Vietnam Pro" pitchFamily="34" charset="-122"/>
+                <a:cs typeface="Be Vietnam Pro" pitchFamily="34" charset="-120"/>
+              </a:rPr>
+              <a:t> đủ</a:t>
+            </a:r>
+            <a:r>
+              <a:rPr lang="en-US" sz="1800" dirty="0" spc="13" kern="0">
+                <a:solidFill>
+                  <a:srgbClr val="9AA0B5"/>
+                </a:solidFill>
+                <a:latin typeface="Be Vietnam Pro" pitchFamily="34" charset="0"/>
+                <a:ea typeface="Be Vietnam Pro" pitchFamily="34" charset="-122"/>
+                <a:cs typeface="Be Vietnam Pro" pitchFamily="34" charset="-120"/>
+              </a:rPr>
+              <a:t> điều</a:t>
+            </a:r>
+            <a:r>
+              <a:rPr lang="en-US" sz="1800" dirty="0" spc="-2" kern="0">
+                <a:solidFill>
+                  <a:srgbClr val="9AA0B5"/>
+                </a:solidFill>
+                <a:latin typeface="Be Vietnam Pro" pitchFamily="34" charset="0"/>
+                <a:ea typeface="Be Vietnam Pro" pitchFamily="34" charset="-122"/>
+                <a:cs typeface="Be Vietnam Pro" pitchFamily="34" charset="-120"/>
+              </a:rPr>
+              <a:t> kiện;</a:t>
+            </a:r>
+            <a:r>
+              <a:rPr lang="en-US" sz="1800" dirty="0" spc="7" kern="0">
+                <a:solidFill>
+                  <a:srgbClr val="9AA0B5"/>
+                </a:solidFill>
+                <a:latin typeface="Be Vietnam Pro" pitchFamily="34" charset="0"/>
+                <a:ea typeface="Be Vietnam Pro" pitchFamily="34" charset="-122"/>
+                <a:cs typeface="Be Vietnam Pro" pitchFamily="34" charset="-120"/>
+              </a:rPr>
+              <a:t> chưa</a:t>
+            </a:r>
+            <a:r>
+              <a:rPr lang="en-US" sz="1800" dirty="0" spc="2" kern="0">
+                <a:solidFill>
+                  <a:srgbClr val="9AA0B5"/>
+                </a:solidFill>
+                <a:latin typeface="Be Vietnam Pro" pitchFamily="34" charset="0"/>
+                <a:ea typeface="Be Vietnam Pro" pitchFamily="34" charset="-122"/>
+                <a:cs typeface="Be Vietnam Pro" pitchFamily="34" charset="-120"/>
+              </a:rPr>
+              <a:t> có</a:t>
+            </a:r>
+            <a:r>
+              <a:rPr lang="en-US" sz="1800" dirty="0" spc="-6" kern="0">
+                <a:solidFill>
+                  <a:srgbClr val="9AA0B5"/>
+                </a:solidFill>
+                <a:latin typeface="Be Vietnam Pro" pitchFamily="34" charset="0"/>
+                <a:ea typeface="Be Vietnam Pro" pitchFamily="34" charset="-122"/>
+                <a:cs typeface="Be Vietnam Pro" pitchFamily="34" charset="-120"/>
+              </a:rPr>
+              <a:t> số</a:t>
+            </a:r>
+            <a:r>
+              <a:rPr lang="en-US" sz="1800" dirty="0" spc="-2" kern="0">
+                <a:solidFill>
+                  <a:srgbClr val="9AA0B5"/>
+                </a:solidFill>
+                <a:latin typeface="Be Vietnam Pro" pitchFamily="34" charset="0"/>
+                <a:ea typeface="Be Vietnam Pro" pitchFamily="34" charset="-122"/>
+                <a:cs typeface="Be Vietnam Pro" pitchFamily="34" charset="-120"/>
+              </a:rPr>
+              <a:t> liệu công</a:t>
+            </a:r>
+            <a:r>
+              <a:rPr lang="en-US" sz="1800" dirty="0" spc="-3" kern="0">
+                <a:solidFill>
+                  <a:srgbClr val="9AA0B5"/>
+                </a:solidFill>
+                <a:latin typeface="Be Vietnam Pro" pitchFamily="34" charset="0"/>
+                <a:ea typeface="Be Vietnam Pro" pitchFamily="34" charset="-122"/>
+                <a:cs typeface="Be Vietnam Pro" pitchFamily="34" charset="-120"/>
+              </a:rPr>
+              <a:t> bố</a:t>
+            </a:r>
+            <a:r>
+              <a:rPr lang="en-US" sz="1800" dirty="0" spc="-13" kern="0">
+                <a:solidFill>
+                  <a:srgbClr val="9AA0B5"/>
+                </a:solidFill>
+                <a:latin typeface="Be Vietnam Pro" pitchFamily="34" charset="0"/>
+                <a:ea typeface="Be Vietnam Pro" pitchFamily="34" charset="-122"/>
+                <a:cs typeface="Be Vietnam Pro" pitchFamily="34" charset="-120"/>
+              </a:rPr>
+              <a:t> về</a:t>
+            </a:r>
+            <a:r>
+              <a:rPr lang="en-US" sz="1800" dirty="0" spc="-7" kern="0">
+                <a:solidFill>
+                  <a:srgbClr val="9AA0B5"/>
+                </a:solidFill>
+                <a:latin typeface="Be Vietnam Pro" pitchFamily="34" charset="0"/>
+                <a:ea typeface="Be Vietnam Pro" pitchFamily="34" charset="-122"/>
+                <a:cs typeface="Be Vietnam Pro" pitchFamily="34" charset="-120"/>
+              </a:rPr>
+              <a:t> tỷ</a:t>
+            </a:r>
+            <a:r>
+              <a:rPr lang="en-US" sz="1800" dirty="0" spc="-2" kern="0">
+                <a:solidFill>
+                  <a:srgbClr val="9AA0B5"/>
+                </a:solidFill>
+                <a:latin typeface="Be Vietnam Pro" pitchFamily="34" charset="0"/>
+                <a:ea typeface="Be Vietnam Pro" pitchFamily="34" charset="-122"/>
+                <a:cs typeface="Be Vietnam Pro" pitchFamily="34" charset="-120"/>
+              </a:rPr>
+              <a:t> lệ</a:t>
+            </a:r>
+            <a:r>
+              <a:rPr lang="en-US" sz="1800" dirty="0" spc="4" kern="0">
+                <a:solidFill>
+                  <a:srgbClr val="9AA0B5"/>
+                </a:solidFill>
+                <a:latin typeface="Be Vietnam Pro" pitchFamily="34" charset="0"/>
+                <a:ea typeface="Be Vietnam Pro" pitchFamily="34" charset="-122"/>
+                <a:cs typeface="Be Vietnam Pro" pitchFamily="34" charset="-120"/>
+              </a:rPr>
+              <a:t> lượt</a:t>
+            </a:r>
+            <a:r>
+              <a:rPr lang="en-US" sz="1800" dirty="0" spc="2" kern="0">
+                <a:solidFill>
+                  <a:srgbClr val="9AA0B5"/>
+                </a:solidFill>
+                <a:latin typeface="Be Vietnam Pro" pitchFamily="34" charset="0"/>
+                <a:ea typeface="Be Vietnam Pro" pitchFamily="34" charset="-122"/>
+                <a:cs typeface="Be Vietnam Pro" pitchFamily="34" charset="-120"/>
+              </a:rPr>
+              <a:t> đủ</a:t>
+            </a:r>
+            <a:r>
+              <a:rPr lang="en-US" sz="1800" dirty="0" spc="13" kern="0">
+                <a:solidFill>
+                  <a:srgbClr val="9AA0B5"/>
+                </a:solidFill>
+                <a:latin typeface="Be Vietnam Pro" pitchFamily="34" charset="0"/>
+                <a:ea typeface="Be Vietnam Pro" pitchFamily="34" charset="-122"/>
+                <a:cs typeface="Be Vietnam Pro" pitchFamily="34" charset="-120"/>
+              </a:rPr>
+              <a:t> điều</a:t>
+            </a:r>
+            <a:r>
+              <a:rPr lang="en-US" sz="1800" dirty="0" spc="-2" kern="0">
+                <a:solidFill>
+                  <a:srgbClr val="9AA0B5"/>
+                </a:solidFill>
+                <a:latin typeface="Be Vietnam Pro" pitchFamily="34" charset="0"/>
+                <a:ea typeface="Be Vietnam Pro" pitchFamily="34" charset="-122"/>
+                <a:cs typeface="Be Vietnam Pro" pitchFamily="34" charset="-120"/>
+              </a:rPr>
+              <a:t> kiện,</a:t>
+            </a:r>
+            <a:r>
+              <a:rPr lang="en-US" sz="1800" dirty="0" spc="-4" kern="0">
+                <a:solidFill>
+                  <a:srgbClr val="9AA0B5"/>
+                </a:solidFill>
+                <a:latin typeface="Be Vietnam Pro" pitchFamily="34" charset="0"/>
+                <a:ea typeface="Be Vietnam Pro" pitchFamily="34" charset="-122"/>
+                <a:cs typeface="Be Vietnam Pro" pitchFamily="34" charset="-120"/>
+              </a:rPr>
+              <a:t> nên</a:t>
+            </a:r>
+            <a:r>
+              <a:rPr lang="en-US" sz="1800" dirty="0" spc="-5" kern="0">
+                <a:solidFill>
+                  <a:srgbClr val="9AA0B5"/>
+                </a:solidFill>
+                <a:latin typeface="Be Vietnam Pro" pitchFamily="34" charset="0"/>
+                <a:ea typeface="Be Vietnam Pro" pitchFamily="34" charset="-122"/>
+                <a:cs typeface="Be Vietnam Pro" pitchFamily="34" charset="-120"/>
+              </a:rPr>
+              <a:t> số</a:t>
+            </a:r>
+            <a:r>
+              <a:rPr lang="en-US" sz="1800" dirty="0" spc="6" kern="0">
+                <a:solidFill>
+                  <a:srgbClr val="9AA0B5"/>
+                </a:solidFill>
+                <a:latin typeface="Be Vietnam Pro" pitchFamily="34" charset="0"/>
+                <a:ea typeface="Be Vietnam Pro" pitchFamily="34" charset="-122"/>
+                <a:cs typeface="Be Vietnam Pro" pitchFamily="34" charset="-120"/>
+              </a:rPr>
+              <a:t> thực</a:t>
+            </a:r>
+            <a:r>
+              <a:rPr lang="en-US" sz="1800" dirty="0" spc="-15" kern="0">
+                <a:solidFill>
+                  <a:srgbClr val="9AA0B5"/>
+                </a:solidFill>
+                <a:latin typeface="Be Vietnam Pro" pitchFamily="34" charset="0"/>
+                <a:ea typeface="Be Vietnam Pro" pitchFamily="34" charset="-122"/>
+                <a:cs typeface="Be Vietnam Pro" pitchFamily="34" charset="-120"/>
+              </a:rPr>
+              <a:t> tế</a:t>
+            </a:r>
+            <a:r>
+              <a:rPr lang="en-US" sz="1800" dirty="0" spc="1" kern="0">
+                <a:solidFill>
+                  <a:srgbClr val="9AA0B5"/>
+                </a:solidFill>
+                <a:latin typeface="Be Vietnam Pro" pitchFamily="34" charset="0"/>
+                <a:ea typeface="Be Vietnam Pro" pitchFamily="34" charset="-122"/>
+                <a:cs typeface="Be Vietnam Pro" pitchFamily="34" charset="-120"/>
+              </a:rPr>
+              <a:t> có</a:t>
+            </a:r>
+            <a:r>
+              <a:rPr lang="en-US" sz="1800" dirty="0" spc="-2" kern="0">
+                <a:solidFill>
+                  <a:srgbClr val="9AA0B5"/>
+                </a:solidFill>
+                <a:latin typeface="Be Vietnam Pro" pitchFamily="34" charset="0"/>
+                <a:ea typeface="Be Vietnam Pro" pitchFamily="34" charset="-122"/>
+                <a:cs typeface="Be Vietnam Pro" pitchFamily="34" charset="-120"/>
+              </a:rPr>
+              <a:t> thể</a:t>
             </a:r>
             <a:r>
               <a:rPr lang="en-US" sz="1800" dirty="0" spc="-1" kern="0">
@@ -21977,10 +22263,10 @@
                 <a:ea typeface="Be Vietnam Pro" pitchFamily="34" charset="-122"/>
                 <a:cs typeface="Be Vietnam Pro" pitchFamily="34" charset="-120"/>
               </a:rPr>
-              <a:t> RPM</a:t>
-            </a:r>
-            <a:r>
-              <a:rPr lang="en-US" sz="1800" dirty="0" spc="0" kern="0">
+              <a:t> thấp</a:t>
+            </a:r>
+            <a:r>
+              <a:rPr lang="en-US" sz="1800" dirty="0" spc="1" kern="0">
                 <a:solidFill>
                   <a:srgbClr val="9AA0B5"/>
                 </a:solidFill>
@@ -21988,175 +22274,21 @@
                 <a:ea typeface="Be Vietnam Pro" pitchFamily="34" charset="-122"/>
                 <a:cs typeface="Be Vietnam Pro" pitchFamily="34" charset="-120"/>
               </a:rPr>
-              <a:t> áp</a:t>
+              <a:t> hơn.</a:t>
+            </a:r>
+            <a:r>
+              <a:rPr lang="en-US" sz="1800" dirty="0" spc="5" kern="0">
+                <a:solidFill>
+                  <a:srgbClr val="9AA0B5"/>
+                </a:solidFill>
+                <a:latin typeface="Be Vietnam Pro" pitchFamily="34" charset="0"/>
+                <a:ea typeface="Be Vietnam Pro" pitchFamily="34" charset="-122"/>
+                <a:cs typeface="Be Vietnam Pro" pitchFamily="34" charset="-120"/>
+              </a:rPr>
+              <a:t> Chưa</a:t>
             </a:r>
             <a:r>
               <a:rPr lang="en-US" sz="1800" dirty="0" spc="-2" kern="0">
-                <a:solidFill>
-                  <a:srgbClr val="9AA0B5"/>
-                </a:solidFill>
-                <a:latin typeface="Be Vietnam Pro" pitchFamily="34" charset="0"/>
-                <a:ea typeface="Be Vietnam Pro" pitchFamily="34" charset="-122"/>
-                <a:cs typeface="Be Vietnam Pro" pitchFamily="34" charset="-120"/>
-              </a:rPr>
-              <a:t> dụng</a:t>
-            </a:r>
-            <a:r>
-              <a:rPr lang="en-US" sz="1800" dirty="0" spc="3" kern="0">
-                <a:solidFill>
-                  <a:srgbClr val="9AA0B5"/>
-                </a:solidFill>
-                <a:latin typeface="Be Vietnam Pro" pitchFamily="34" charset="0"/>
-                <a:ea typeface="Be Vietnam Pro" pitchFamily="34" charset="-122"/>
-                <a:cs typeface="Be Vietnam Pro" pitchFamily="34" charset="-120"/>
-              </a:rPr>
-              <a:t> cho</a:t>
-            </a:r>
-            <a:r>
-              <a:rPr lang="en-US" sz="1800" dirty="0" spc="-2" kern="0">
-                <a:solidFill>
-                  <a:srgbClr val="9AA0B5"/>
-                </a:solidFill>
-                <a:latin typeface="Be Vietnam Pro" pitchFamily="34" charset="0"/>
-                <a:ea typeface="Be Vietnam Pro" pitchFamily="34" charset="-122"/>
-                <a:cs typeface="Be Vietnam Pro" pitchFamily="34" charset="-120"/>
-              </a:rPr>
-              <a:t> khoảng</a:t>
-            </a:r>
-            <a:r>
-              <a:rPr lang="en-US" sz="1800" dirty="0" spc="2" kern="0">
-                <a:solidFill>
-                  <a:srgbClr val="9AA0B5"/>
-                </a:solidFill>
-                <a:latin typeface="Be Vietnam Pro" pitchFamily="34" charset="0"/>
-                <a:ea typeface="Be Vietnam Pro" pitchFamily="34" charset="-122"/>
-                <a:cs typeface="Be Vietnam Pro" pitchFamily="34" charset="-120"/>
-              </a:rPr>
-              <a:t> 40</a:t>
-            </a:r>
-            <a:r>
-              <a:rPr lang="en-US" sz="1800" dirty="0" spc="8" kern="0">
-                <a:solidFill>
-                  <a:srgbClr val="9AA0B5"/>
-                </a:solidFill>
-                <a:latin typeface="Be Vietnam Pro" pitchFamily="34" charset="0"/>
-                <a:ea typeface="Be Vietnam Pro" pitchFamily="34" charset="-122"/>
-                <a:cs typeface="Be Vietnam Pro" pitchFamily="34" charset="-120"/>
-              </a:rPr>
-              <a:t> đến</a:t>
-            </a:r>
-            <a:r>
-              <a:rPr lang="en-US" sz="1800" dirty="0" spc="-21" kern="0">
-                <a:solidFill>
-                  <a:srgbClr val="9AA0B5"/>
-                </a:solidFill>
-                <a:latin typeface="Be Vietnam Pro" pitchFamily="34" charset="0"/>
-                <a:ea typeface="Be Vietnam Pro" pitchFamily="34" charset="-122"/>
-                <a:cs typeface="Be Vietnam Pro" pitchFamily="34" charset="-120"/>
-              </a:rPr>
-              <a:t> 70%</a:t>
-            </a:r>
-            <a:r>
-              <a:rPr lang="en-US" sz="1800" dirty="0" spc="-11" kern="0">
-                <a:solidFill>
-                  <a:srgbClr val="9AA0B5"/>
-                </a:solidFill>
-                <a:latin typeface="Be Vietnam Pro" pitchFamily="34" charset="0"/>
-                <a:ea typeface="Be Vietnam Pro" pitchFamily="34" charset="-122"/>
-                <a:cs typeface="Be Vietnam Pro" pitchFamily="34" charset="-120"/>
-              </a:rPr>
-              <a:t> tổng</a:t>
-            </a:r>
-            <a:r>
-              <a:rPr lang="en-US" sz="1800" dirty="0" spc="4" kern="0">
-                <a:solidFill>
-                  <a:srgbClr val="9AA0B5"/>
-                </a:solidFill>
-                <a:latin typeface="Be Vietnam Pro" pitchFamily="34" charset="0"/>
-                <a:ea typeface="Be Vietnam Pro" pitchFamily="34" charset="-122"/>
-                <a:cs typeface="Be Vietnam Pro" pitchFamily="34" charset="-120"/>
-              </a:rPr>
-              <a:t> lượt</a:t>
-            </a:r>
-            <a:r>
-              <a:rPr lang="en-US" sz="1800" dirty="0" spc="-12" kern="0">
-                <a:solidFill>
-                  <a:srgbClr val="9AA0B5"/>
-                </a:solidFill>
-                <a:latin typeface="Be Vietnam Pro" pitchFamily="34" charset="0"/>
-                <a:ea typeface="Be Vietnam Pro" pitchFamily="34" charset="-122"/>
-                <a:cs typeface="Be Vietnam Pro" pitchFamily="34" charset="-120"/>
-              </a:rPr>
-              <a:t> xem</a:t>
-            </a:r>
-            <a:r>
-              <a:rPr lang="en-US" sz="1800" dirty="0" spc="3" kern="0">
-                <a:solidFill>
-                  <a:srgbClr val="9AA0B5"/>
-                </a:solidFill>
-                <a:latin typeface="Be Vietnam Pro" pitchFamily="34" charset="0"/>
-                <a:ea typeface="Be Vietnam Pro" pitchFamily="34" charset="-122"/>
-                <a:cs typeface="Be Vietnam Pro" pitchFamily="34" charset="-120"/>
-              </a:rPr>
-              <a:t> (lượt</a:t>
-            </a:r>
-            <a:r>
-              <a:rPr lang="en-US" sz="1800" dirty="0" spc="-11" kern="0">
-                <a:solidFill>
-                  <a:srgbClr val="9AA0B5"/>
-                </a:solidFill>
-                <a:latin typeface="Be Vietnam Pro" pitchFamily="34" charset="0"/>
-                <a:ea typeface="Be Vietnam Pro" pitchFamily="34" charset="-122"/>
-                <a:cs typeface="Be Vietnam Pro" pitchFamily="34" charset="-120"/>
-              </a:rPr>
-              <a:t> xem</a:t>
-            </a:r>
-            <a:r>
-              <a:rPr lang="en-US" sz="1800" dirty="0" spc="2" kern="0">
-                <a:solidFill>
-                  <a:srgbClr val="9AA0B5"/>
-                </a:solidFill>
-                <a:latin typeface="Be Vietnam Pro" pitchFamily="34" charset="0"/>
-                <a:ea typeface="Be Vietnam Pro" pitchFamily="34" charset="-122"/>
-                <a:cs typeface="Be Vietnam Pro" pitchFamily="34" charset="-120"/>
-              </a:rPr>
-              <a:t> đủ</a:t>
-            </a:r>
-            <a:r>
-              <a:rPr lang="en-US" sz="1800" dirty="0" spc="13" kern="0">
-                <a:solidFill>
-                  <a:srgbClr val="9AA0B5"/>
-                </a:solidFill>
-                <a:latin typeface="Be Vietnam Pro" pitchFamily="34" charset="0"/>
-                <a:ea typeface="Be Vietnam Pro" pitchFamily="34" charset="-122"/>
-                <a:cs typeface="Be Vietnam Pro" pitchFamily="34" charset="-120"/>
-              </a:rPr>
-              <a:t> điều</a:t>
-            </a:r>
-            <a:r>
-              <a:rPr lang="en-US" sz="1800" dirty="0" spc="-1" kern="0">
-                <a:solidFill>
-                  <a:srgbClr val="9AA0B5"/>
-                </a:solidFill>
-                <a:latin typeface="Be Vietnam Pro" pitchFamily="34" charset="0"/>
-                <a:ea typeface="Be Vietnam Pro" pitchFamily="34" charset="-122"/>
-                <a:cs typeface="Be Vietnam Pro" pitchFamily="34" charset="-120"/>
-              </a:rPr>
-              <a:t> kiện);</a:t>
-            </a:r>
-            <a:r>
-              <a:rPr lang="en-US" sz="1800" dirty="0" spc="7" kern="0">
-                <a:solidFill>
-                  <a:srgbClr val="9AA0B5"/>
-                </a:solidFill>
-                <a:latin typeface="Be Vietnam Pro" pitchFamily="34" charset="0"/>
-                <a:ea typeface="Be Vietnam Pro" pitchFamily="34" charset="-122"/>
-                <a:cs typeface="Be Vietnam Pro" pitchFamily="34" charset="-120"/>
-              </a:rPr>
-              <a:t> chưa</a:t>
-            </a:r>
-            <a:r>
-              <a:rPr lang="en-US" sz="1800" dirty="0" spc="-3" kern="0">
                 <a:solidFill>
                   <a:srgbClr val="9AA0B5"/>
                 </a:solidFill>

</xml_diff>

<commit_message>
Label the small-group rollout model as a third-party description
The summary tagged "platforms test a video on a small group, then expand" as
official for YouTube and TikTok, while section 2.1 tagged the same claim as
third-party. The official pages describe choosing videos per viewer and name no
staged rollout. Say so in the summary and in 2.1, and add a caption under the
three-step flow on slide 3. The deck is re-exported from Moda, so the free-plan
moda.app badge stays on every slide.

Co-Authored-By: Claude Sonnet 5.5 <noreply@anthropic.com>
Claude-Session: https://claude.ai/code/session_018uW6gkgn9CUzNGw4ERV2G7
</commit_message>
<xml_diff>
--- a/research/xu-huong-kiem-tien-youtube-tiktok-facebook.pptx
+++ b/research/xu-huong-kiem-tien-youtube-tiktok-facebook.pptx
@@ -12540,7 +12540,222 @@
       </p:sp>
       <p:sp>
         <p:nvSpPr>
-          <p:cNvPr id="33" name="Shape 31"/>
+          <p:cNvPr id="33" name="Text 31"/>
+          <p:cNvSpPr/>
+          <p:nvPr/>
+        </p:nvSpPr>
+        <p:spPr>
+          <a:xfrm>
+            <a:off x="914400" y="3505200"/>
+            <a:ext cx="16459200" cy="323850"/>
+          </a:xfrm>
+          <a:prstGeom prst="rect">
+            <a:avLst/>
+          </a:prstGeom>
+          <a:noFill/>
+          <a:ln/>
+        </p:spPr>
+        <p:txBody>
+          <a:bodyPr wrap="square" lIns="0" tIns="0" rIns="0" bIns="0" rtlCol="0" anchor="t"/>
+          <a:lstStyle/>
+          <a:p>
+            <a:pPr algn="l" indent="0" marL="0">
+              <a:buNone/>
+            </a:pPr>
+            <a:r>
+              <a:rPr lang="en-US" sz="1800" dirty="0" spc="-2" kern="0">
+                <a:solidFill>
+                  <a:srgbClr val="6B6A66"/>
+                </a:solidFill>
+                <a:latin typeface="Be Vietnam Pro" pitchFamily="34" charset="0"/>
+                <a:ea typeface="Be Vietnam Pro" pitchFamily="34" charset="-122"/>
+                <a:cs typeface="Be Vietnam Pro" pitchFamily="34" charset="-120"/>
+              </a:rPr>
+              <a:t>Mô hình</a:t>
+            </a:r>
+            <a:r>
+              <a:rPr lang="en-US" sz="1800" dirty="0" spc="0" kern="0">
+                <a:solidFill>
+                  <a:srgbClr val="6B6A66"/>
+                </a:solidFill>
+                <a:latin typeface="Be Vietnam Pro" pitchFamily="34" charset="0"/>
+                <a:ea typeface="Be Vietnam Pro" pitchFamily="34" charset="-122"/>
+                <a:cs typeface="Be Vietnam Pro" pitchFamily="34" charset="-120"/>
+              </a:rPr>
+              <a:t> phổ</a:t>
+            </a:r>
+            <a:r>
+              <a:rPr lang="en-US" sz="1800" dirty="0" spc="-2" kern="0">
+                <a:solidFill>
+                  <a:srgbClr val="6B6A66"/>
+                </a:solidFill>
+                <a:latin typeface="Be Vietnam Pro" pitchFamily="34" charset="0"/>
+                <a:ea typeface="Be Vietnam Pro" pitchFamily="34" charset="-122"/>
+                <a:cs typeface="Be Vietnam Pro" pitchFamily="34" charset="-120"/>
+              </a:rPr>
+              <a:t> biến</a:t>
+            </a:r>
+            <a:r>
+              <a:rPr lang="en-US" sz="1800" dirty="0" spc="-1" kern="0">
+                <a:solidFill>
+                  <a:srgbClr val="6B6A66"/>
+                </a:solidFill>
+                <a:latin typeface="Be Vietnam Pro" pitchFamily="34" charset="0"/>
+                <a:ea typeface="Be Vietnam Pro" pitchFamily="34" charset="-122"/>
+                <a:cs typeface="Be Vietnam Pro" pitchFamily="34" charset="-120"/>
+              </a:rPr>
+              <a:t> theo</a:t>
+            </a:r>
+            <a:r>
+              <a:rPr lang="en-US" sz="1800" dirty="0" spc="-4" kern="0">
+                <a:solidFill>
+                  <a:srgbClr val="6B6A66"/>
+                </a:solidFill>
+                <a:latin typeface="Be Vietnam Pro" pitchFamily="34" charset="0"/>
+                <a:ea typeface="Be Vietnam Pro" pitchFamily="34" charset="-122"/>
+                <a:cs typeface="Be Vietnam Pro" pitchFamily="34" charset="-120"/>
+              </a:rPr>
+              <a:t> bên</a:t>
+            </a:r>
+            <a:r>
+              <a:rPr lang="en-US" sz="1800" dirty="0" spc="-1" kern="0">
+                <a:solidFill>
+                  <a:srgbClr val="6B6A66"/>
+                </a:solidFill>
+                <a:latin typeface="Be Vietnam Pro" pitchFamily="34" charset="0"/>
+                <a:ea typeface="Be Vietnam Pro" pitchFamily="34" charset="-122"/>
+                <a:cs typeface="Be Vietnam Pro" pitchFamily="34" charset="-120"/>
+              </a:rPr>
+              <a:t> thứ ba</a:t>
+            </a:r>
+            <a:r>
+              <a:rPr lang="en-US" sz="1800" dirty="0" spc="-12" kern="0">
+                <a:solidFill>
+                  <a:srgbClr val="6B6A66"/>
+                </a:solidFill>
+                <a:latin typeface="Be Vietnam Pro" pitchFamily="34" charset="0"/>
+                <a:ea typeface="Be Vietnam Pro" pitchFamily="34" charset="-122"/>
+                <a:cs typeface="Be Vietnam Pro" pitchFamily="34" charset="-120"/>
+              </a:rPr>
+              <a:t> và</a:t>
+            </a:r>
+            <a:r>
+              <a:rPr lang="en-US" sz="1800" dirty="0" spc="3" kern="0">
+                <a:solidFill>
+                  <a:srgbClr val="6B6A66"/>
+                </a:solidFill>
+                <a:latin typeface="Be Vietnam Pro" pitchFamily="34" charset="0"/>
+                <a:ea typeface="Be Vietnam Pro" pitchFamily="34" charset="-122"/>
+                <a:cs typeface="Be Vietnam Pro" pitchFamily="34" charset="-120"/>
+              </a:rPr>
+              <a:t> người</a:t>
+            </a:r>
+            <a:r>
+              <a:rPr lang="en-US" sz="1800" dirty="0" spc="-2" kern="0">
+                <a:solidFill>
+                  <a:srgbClr val="6B6A66"/>
+                </a:solidFill>
+                <a:latin typeface="Be Vietnam Pro" pitchFamily="34" charset="0"/>
+                <a:ea typeface="Be Vietnam Pro" pitchFamily="34" charset="-122"/>
+                <a:cs typeface="Be Vietnam Pro" pitchFamily="34" charset="-120"/>
+              </a:rPr>
+              <a:t> làm nội</a:t>
+            </a:r>
+            <a:r>
+              <a:rPr lang="en-US" sz="1800" dirty="0" spc="-3" kern="0">
+                <a:solidFill>
+                  <a:srgbClr val="6B6A66"/>
+                </a:solidFill>
+                <a:latin typeface="Be Vietnam Pro" pitchFamily="34" charset="0"/>
+                <a:ea typeface="Be Vietnam Pro" pitchFamily="34" charset="-122"/>
+                <a:cs typeface="Be Vietnam Pro" pitchFamily="34" charset="-120"/>
+              </a:rPr>
+              <a:t> dung,</a:t>
+            </a:r>
+            <a:r>
+              <a:rPr lang="en-US" sz="1800" dirty="0" spc="-2" kern="0">
+                <a:solidFill>
+                  <a:srgbClr val="6B6A66"/>
+                </a:solidFill>
+                <a:latin typeface="Be Vietnam Pro" pitchFamily="34" charset="0"/>
+                <a:ea typeface="Be Vietnam Pro" pitchFamily="34" charset="-122"/>
+                <a:cs typeface="Be Vietnam Pro" pitchFamily="34" charset="-120"/>
+              </a:rPr>
+              <a:t> không</a:t>
+            </a:r>
+            <a:r>
+              <a:rPr lang="en-US" sz="1800" dirty="0" spc="-1" kern="0">
+                <a:solidFill>
+                  <a:srgbClr val="6B6A66"/>
+                </a:solidFill>
+                <a:latin typeface="Be Vietnam Pro" pitchFamily="34" charset="0"/>
+                <a:ea typeface="Be Vietnam Pro" pitchFamily="34" charset="-122"/>
+                <a:cs typeface="Be Vietnam Pro" pitchFamily="34" charset="-120"/>
+              </a:rPr>
+              <a:t> phải</a:t>
+            </a:r>
+            <a:r>
+              <a:rPr lang="en-US" sz="1800" dirty="0" spc="14" kern="0">
+                <a:solidFill>
+                  <a:srgbClr val="6B6A66"/>
+                </a:solidFill>
+                <a:latin typeface="Be Vietnam Pro" pitchFamily="34" charset="0"/>
+                <a:ea typeface="Be Vietnam Pro" pitchFamily="34" charset="-122"/>
+                <a:cs typeface="Be Vietnam Pro" pitchFamily="34" charset="-120"/>
+              </a:rPr>
+              <a:t> điều</a:t>
+            </a:r>
+            <a:r>
+              <a:rPr lang="en-US" sz="1800" dirty="0" spc="-4" kern="0">
+                <a:solidFill>
+                  <a:srgbClr val="6B6A66"/>
+                </a:solidFill>
+                <a:latin typeface="Be Vietnam Pro" pitchFamily="34" charset="0"/>
+                <a:ea typeface="Be Vietnam Pro" pitchFamily="34" charset="-122"/>
+                <a:cs typeface="Be Vietnam Pro" pitchFamily="34" charset="-120"/>
+              </a:rPr>
+              <a:t> nền</a:t>
+            </a:r>
+            <a:r>
+              <a:rPr lang="en-US" sz="1800" dirty="0" spc="-10" kern="0">
+                <a:solidFill>
+                  <a:srgbClr val="6B6A66"/>
+                </a:solidFill>
+                <a:latin typeface="Be Vietnam Pro" pitchFamily="34" charset="0"/>
+                <a:ea typeface="Be Vietnam Pro" pitchFamily="34" charset="-122"/>
+                <a:cs typeface="Be Vietnam Pro" pitchFamily="34" charset="-120"/>
+              </a:rPr>
+              <a:t> tảng</a:t>
+            </a:r>
+            <a:r>
+              <a:rPr lang="en-US" sz="1800" dirty="0" spc="-1" kern="0">
+                <a:solidFill>
+                  <a:srgbClr val="6B6A66"/>
+                </a:solidFill>
+                <a:latin typeface="Be Vietnam Pro" pitchFamily="34" charset="0"/>
+                <a:ea typeface="Be Vietnam Pro" pitchFamily="34" charset="-122"/>
+                <a:cs typeface="Be Vietnam Pro" pitchFamily="34" charset="-120"/>
+              </a:rPr>
+              <a:t> công</a:t>
+            </a:r>
+            <a:r>
+              <a:rPr lang="en-US" sz="1800" dirty="0" spc="-2" kern="0">
+                <a:solidFill>
+                  <a:srgbClr val="6B6A66"/>
+                </a:solidFill>
+                <a:latin typeface="Be Vietnam Pro" pitchFamily="34" charset="0"/>
+                <a:ea typeface="Be Vietnam Pro" pitchFamily="34" charset="-122"/>
+                <a:cs typeface="Be Vietnam Pro" pitchFamily="34" charset="-120"/>
+              </a:rPr>
+              <a:t> bố.</a:t>
+            </a:r>
+            <a:endParaRPr lang="en-US" sz="1800" dirty="0"/>
+          </a:p>
+        </p:txBody>
+      </p:sp>
+      <p:sp>
+        <p:nvSpPr>
+          <p:cNvPr id="34" name="Shape 32"/>
           <p:cNvSpPr/>
           <p:nvPr/>
         </p:nvSpPr>
@@ -12564,7 +12779,7 @@
       </p:sp>
       <p:pic>
         <p:nvPicPr>
-          <p:cNvPr id="34" name="Moda image moda-export-watermark-f967e795-6ee8-4a29-90ce-00c3bd48a956" descr="">    </p:cNvPr>
+          <p:cNvPr id="35" name="Moda image moda-export-watermark-f967e795-6ee8-4a29-90ce-00c3bd48a956" descr="">    </p:cNvPr>
           <p:cNvPicPr>
             <a:picLocks noChangeAspect="1"/>
           </p:cNvPicPr>

</xml_diff>

<commit_message>
Hedge claims the report could not fully support
Say what was read rather than what no platform does: the AI and API summary line
now reads "I did not find", slide 11 reads "No platform document seen says",
and the conclusion no longer calls YouTube the only platform open to Vietnam
(Facebook's pages name no country list). Mark the creator advice in the
conclusion as experience, and note under the RPM table that the three niche
long-form ranges have no named source yet. The deck is re-exported from Moda, so
the free-plan moda.app badge stays on every slide.

Co-Authored-By: Claude Sonnet 5.5 <noreply@anthropic.com>
Claude-Session: https://claude.ai/code/session_018uW6gkgn9CUzNGw4ERV2G7
</commit_message>
<xml_diff>
--- a/research/xu-huong-kiem-tien-youtube-tiktok-facebook.pptx
+++ b/research/xu-huong-kiem-tien-youtube-tiktok-facebook.pptx
@@ -6155,7 +6155,7 @@
               <a:buNone/>
             </a:pPr>
             <a:r>
-              <a:rPr lang="en-US" sz="3000" dirty="0" spc="-2" kern="0">
+              <a:rPr lang="en-US" sz="3000" dirty="0" spc="-22" kern="0">
                 <a:solidFill>
                   <a:srgbClr val="14161C"/>
                 </a:solidFill>
@@ -6163,10 +6163,10 @@
                 <a:ea typeface="Bricolage Grotesque ExtraBold" pitchFamily="34" charset="-122"/>
                 <a:cs typeface="Bricolage Grotesque ExtraBold" pitchFamily="34" charset="-120"/>
               </a:rPr>
-              <a:t>Không</a:t>
-            </a:r>
-            <a:r>
-              <a:rPr lang="en-US" sz="3000" dirty="0" spc="-1" kern="0">
+              <a:t>Chưa</a:t>
+            </a:r>
+            <a:r>
+              <a:rPr lang="en-US" sz="3000" dirty="0" spc="2" kern="0">
                 <a:solidFill>
                   <a:srgbClr val="14161C"/>
                 </a:solidFill>
@@ -6174,10 +6174,10 @@
                 <a:ea typeface="Bricolage Grotesque ExtraBold" pitchFamily="34" charset="-122"/>
                 <a:cs typeface="Bricolage Grotesque ExtraBold" pitchFamily="34" charset="-120"/>
               </a:rPr>
-              <a:t> nền</a:t>
-            </a:r>
-            <a:r>
-              <a:rPr lang="en-US" sz="3000" dirty="0" spc="-2" kern="0">
+              <a:t> thấy</a:t>
+            </a:r>
+            <a:r>
+              <a:rPr lang="en-US" sz="3000" dirty="0" spc="-1" kern="0">
                 <a:solidFill>
                   <a:srgbClr val="14161C"/>
                 </a:solidFill>
@@ -6185,7 +6185,7 @@
                 <a:ea typeface="Bricolage Grotesque ExtraBold" pitchFamily="34" charset="-122"/>
                 <a:cs typeface="Bricolage Grotesque ExtraBold" pitchFamily="34" charset="-120"/>
               </a:rPr>
-              <a:t> tảng</a:t>
+              <a:t> tài</a:t>
             </a:r>
             <a:r>
               <a:rPr lang="en-US" sz="3000" dirty="0" spc="1" kern="0">
@@ -6196,10 +6196,10 @@
                 <a:ea typeface="Bricolage Grotesque ExtraBold" pitchFamily="34" charset="-122"/>
                 <a:cs typeface="Bricolage Grotesque ExtraBold" pitchFamily="34" charset="-120"/>
               </a:rPr>
-              <a:t> nào</a:t>
-            </a:r>
-            <a:r>
-              <a:rPr lang="en-US" sz="3000" dirty="0" spc="0" kern="0">
+              <a:t> liệu</a:t>
+            </a:r>
+            <a:r>
+              <a:rPr lang="en-US" sz="3000" dirty="0" spc="-1" kern="0">
                 <a:solidFill>
                   <a:srgbClr val="14161C"/>
                 </a:solidFill>
@@ -6207,7 +6207,18 @@
                 <a:ea typeface="Bricolage Grotesque ExtraBold" pitchFamily="34" charset="-122"/>
                 <a:cs typeface="Bricolage Grotesque ExtraBold" pitchFamily="34" charset="-120"/>
               </a:rPr>
-              <a:t> nói</a:t>
+              <a:t> nền tảng</a:t>
+            </a:r>
+            <a:r>
+              <a:rPr lang="en-US" sz="3000" dirty="0" spc="0" kern="0">
+                <a:solidFill>
+                  <a:srgbClr val="14161C"/>
+                </a:solidFill>
+                <a:latin typeface="Bricolage Grotesque ExtraBold" pitchFamily="34" charset="0"/>
+                <a:ea typeface="Bricolage Grotesque ExtraBold" pitchFamily="34" charset="-122"/>
+                <a:cs typeface="Bricolage Grotesque ExtraBold" pitchFamily="34" charset="-120"/>
+              </a:rPr>
+              <a:t> nào nói</a:t>
             </a:r>
             <a:r>
               <a:rPr lang="en-US" sz="3000" dirty="0" spc="3" kern="0">

</xml_diff>

<commit_message>
Give each RPM figure its own source and date, and cover both YouTube music rules
Shorts: the 0.04-0.10 USD range came from Unilink and Argil, not from the AIR
study; show AIR's niche range, the other sources, and the 0.04-0.20 USD range
used for the estimate. Vietnam: show both Dynamoi snapshots (0.22 USD to
2026-07-14, 0.18 USD to 2026-10-14) as a range and say the newer one was not
re-read. YouTube's disclosure page lists music twice ("the main focus of the
video" in the conditions, "AI generated music" with no condition in the
examples); say so and advise disclosing background music. Slide 7 (log chart)
and slide 8 are re-exported from Moda, so the free-plan moda.app badge stays on
every slide.

Co-Authored-By: Claude Sonnet 5.5 <noreply@anthropic.com>
Claude-Session: https://claude.ai/code/session_018uW6gkgn9CUzNGw4ERV2G7
</commit_message>
<xml_diff>
--- a/research/xu-huong-kiem-tien-youtube-tiktok-facebook.pptx
+++ b/research/xu-huong-kiem-tien-youtube-tiktok-facebook.pptx
@@ -19800,7 +19800,7 @@
               <a:t> đến</a:t>
             </a:r>
             <a:r>
-              <a:rPr lang="en-US" sz="1950" dirty="0" spc="3" kern="0">
+              <a:rPr lang="en-US" sz="1950" dirty="0" spc="2" kern="0">
                 <a:solidFill>
                   <a:srgbClr val="6B6A66"/>
                 </a:solidFill>
@@ -19808,7 +19808,7 @@
                 <a:ea typeface="Be Vietnam Pro" pitchFamily="34" charset="-122"/>
                 <a:cs typeface="Be Vietnam Pro" pitchFamily="34" charset="-120"/>
               </a:rPr>
-              <a:t> 0,10</a:t>
+              <a:t> 0,20</a:t>
             </a:r>
             <a:r>
               <a:rPr lang="en-US" sz="1950" dirty="0" spc="-1" kern="0">
@@ -19834,7 +19834,7 @@
         <p:spPr>
           <a:xfrm>
             <a:off x="8008620" y="4219575"/>
-            <a:ext cx="1389698" cy="323850"/>
+            <a:ext cx="2440305" cy="323850"/>
           </a:xfrm>
           <a:prstGeom prst="roundRect">
             <a:avLst>
@@ -19963,7 +19963,40 @@
                 <a:ea typeface="Be Vietnam Pro" pitchFamily="34" charset="-122"/>
                 <a:cs typeface="Be Vietnam Pro" pitchFamily="34" charset="-120"/>
               </a:rPr>
-              <a:t>khoảng 0,22 USD</a:t>
+              <a:t>khoảng</a:t>
+            </a:r>
+            <a:r>
+              <a:rPr lang="en-US" sz="1950" dirty="0" spc="1" kern="0">
+                <a:solidFill>
+                  <a:srgbClr val="6B6A66"/>
+                </a:solidFill>
+                <a:latin typeface="Be Vietnam Pro" pitchFamily="34" charset="0"/>
+                <a:ea typeface="Be Vietnam Pro" pitchFamily="34" charset="-122"/>
+                <a:cs typeface="Be Vietnam Pro" pitchFamily="34" charset="-120"/>
+              </a:rPr>
+              <a:t> 0,18</a:t>
+            </a:r>
+            <a:r>
+              <a:rPr lang="en-US" sz="1950" dirty="0" spc="12" kern="0">
+                <a:solidFill>
+                  <a:srgbClr val="6B6A66"/>
+                </a:solidFill>
+                <a:latin typeface="Be Vietnam Pro" pitchFamily="34" charset="0"/>
+                <a:ea typeface="Be Vietnam Pro" pitchFamily="34" charset="-122"/>
+                <a:cs typeface="Be Vietnam Pro" pitchFamily="34" charset="-120"/>
+              </a:rPr>
+              <a:t> đến</a:t>
+            </a:r>
+            <a:r>
+              <a:rPr lang="en-US" sz="1950" dirty="0" spc="-1" kern="0">
+                <a:solidFill>
+                  <a:srgbClr val="6B6A66"/>
+                </a:solidFill>
+                <a:latin typeface="Be Vietnam Pro" pitchFamily="34" charset="0"/>
+                <a:ea typeface="Be Vietnam Pro" pitchFamily="34" charset="-122"/>
+                <a:cs typeface="Be Vietnam Pro" pitchFamily="34" charset="-120"/>
+              </a:rPr>
+              <a:t> 0,22 USD</a:t>
             </a:r>
             <a:endParaRPr lang="en-US" sz="1950" dirty="0"/>
           </a:p>
@@ -19977,8 +20010,8 @@
         </p:nvSpPr>
         <p:spPr>
           <a:xfrm>
-            <a:off x="10420350" y="5267325"/>
-            <a:ext cx="342900" cy="342900"/>
+            <a:off x="10118407" y="5267325"/>
+            <a:ext cx="646748" cy="342900"/>
           </a:xfrm>
           <a:prstGeom prst="roundRect">
             <a:avLst>
@@ -20419,7 +20452,7 @@
               <a:buNone/>
             </a:pPr>
             <a:r>
-              <a:rPr lang="en-US" sz="1950" dirty="0" spc="3" kern="0">
+              <a:rPr lang="en-US" sz="1800" dirty="0" spc="-2" kern="0">
                 <a:solidFill>
                   <a:srgbClr val="6B6A66"/>
                 </a:solidFill>
@@ -20430,7 +20463,7 @@
               <a:t>Thang</a:t>
             </a:r>
             <a:r>
-              <a:rPr lang="en-US" sz="1950" dirty="0" spc="-1" kern="0">
+              <a:rPr lang="en-US" sz="1800" dirty="0" spc="0" kern="0">
                 <a:solidFill>
                   <a:srgbClr val="6B6A66"/>
                 </a:solidFill>
@@ -20441,7 +20474,7 @@
               <a:t> logarit.</a:t>
             </a:r>
             <a:r>
-              <a:rPr lang="en-US" sz="1950" dirty="0" spc="-2" kern="0">
+              <a:rPr lang="en-US" sz="1800" dirty="0" spc="1" kern="0">
                 <a:solidFill>
                   <a:srgbClr val="6B6A66"/>
                 </a:solidFill>
@@ -20452,7 +20485,7 @@
               <a:t> Ước</a:t>
             </a:r>
             <a:r>
-              <a:rPr lang="en-US" sz="1950" dirty="0" spc="0" kern="0">
+              <a:rPr lang="en-US" sz="1800" dirty="0" spc="-3" kern="0">
                 <a:solidFill>
                   <a:srgbClr val="6B6A66"/>
                 </a:solidFill>
@@ -20460,10 +20493,10 @@
                 <a:ea typeface="Be Vietnam Pro" pitchFamily="34" charset="-122"/>
                 <a:cs typeface="Be Vietnam Pro" pitchFamily="34" charset="-120"/>
               </a:rPr>
-              <a:t> tính của</a:t>
-            </a:r>
-            <a:r>
-              <a:rPr lang="en-US" sz="1950" dirty="0" spc="-3" kern="0">
+              <a:t> tính</a:t>
+            </a:r>
+            <a:r>
+              <a:rPr lang="en-US" sz="1800" dirty="0" spc="4" kern="0">
                 <a:solidFill>
                   <a:srgbClr val="6B6A66"/>
                 </a:solidFill>
@@ -20471,10 +20504,21 @@
                 <a:ea typeface="Be Vietnam Pro" pitchFamily="34" charset="-122"/>
                 <a:cs typeface="Be Vietnam Pro" pitchFamily="34" charset="-120"/>
               </a:rPr>
+              <a:t> của</a:t>
+            </a:r>
+            <a:r>
+              <a:rPr lang="en-US" sz="1800" dirty="0" spc="-5" kern="0">
+                <a:solidFill>
+                  <a:srgbClr val="6B6A66"/>
+                </a:solidFill>
+                <a:latin typeface="Be Vietnam Pro" pitchFamily="34" charset="0"/>
+                <a:ea typeface="Be Vietnam Pro" pitchFamily="34" charset="-122"/>
+                <a:cs typeface="Be Vietnam Pro" pitchFamily="34" charset="-120"/>
+              </a:rPr>
               <a:t> bên</a:t>
             </a:r>
             <a:r>
-              <a:rPr lang="en-US" sz="1950" dirty="0" spc="0" kern="0">
+              <a:rPr lang="en-US" sz="1800" dirty="0" spc="-1" kern="0">
                 <a:solidFill>
                   <a:srgbClr val="6B6A66"/>
                 </a:solidFill>
@@ -20485,7 +20529,7 @@
               <a:t> thứ</a:t>
             </a:r>
             <a:r>
-              <a:rPr lang="en-US" sz="1950" dirty="0" spc="-5" kern="0">
+              <a:rPr lang="en-US" sz="1800" dirty="0" spc="-2" kern="0">
                 <a:solidFill>
                   <a:srgbClr val="6B6A66"/>
                 </a:solidFill>
@@ -20493,10 +20537,10 @@
                 <a:ea typeface="Be Vietnam Pro" pitchFamily="34" charset="-122"/>
                 <a:cs typeface="Be Vietnam Pro" pitchFamily="34" charset="-120"/>
               </a:rPr>
-              <a:t> ba:</a:t>
-            </a:r>
-            <a:r>
-              <a:rPr lang="en-US" sz="1950" dirty="0" spc="2" kern="0">
+              <a:t> ba,</a:t>
+            </a:r>
+            <a:r>
+              <a:rPr lang="en-US" sz="1800" dirty="0" spc="-3" kern="0">
                 <a:solidFill>
                   <a:srgbClr val="6B6A66"/>
                 </a:solidFill>
@@ -20507,7 +20551,7 @@
               <a:t> nền</a:t>
             </a:r>
             <a:r>
-              <a:rPr lang="en-US" sz="1950" dirty="0" spc="-7" kern="0">
+              <a:rPr lang="en-US" sz="1800" dirty="0" spc="-10" kern="0">
                 <a:solidFill>
                   <a:srgbClr val="6B6A66"/>
                 </a:solidFill>
@@ -20518,7 +20562,7 @@
               <a:t> tảng</a:t>
             </a:r>
             <a:r>
-              <a:rPr lang="en-US" sz="1950" dirty="0" spc="0" kern="0">
+              <a:rPr lang="en-US" sz="1800" dirty="0" spc="-2" kern="0">
                 <a:solidFill>
                   <a:srgbClr val="6B6A66"/>
                 </a:solidFill>
@@ -20526,10 +20570,10 @@
                 <a:ea typeface="Be Vietnam Pro" pitchFamily="34" charset="-122"/>
                 <a:cs typeface="Be Vietnam Pro" pitchFamily="34" charset="-120"/>
               </a:rPr>
-              <a:t> không</a:t>
-            </a:r>
-            <a:r>
-              <a:rPr lang="en-US" sz="1950" dirty="0" spc="-1" kern="0">
+              <a:t> không công</a:t>
+            </a:r>
+            <a:r>
+              <a:rPr lang="en-US" sz="1800" dirty="0" spc="-3" kern="0">
                 <a:solidFill>
                   <a:srgbClr val="6B6A66"/>
                 </a:solidFill>
@@ -20537,10 +20581,10 @@
                 <a:ea typeface="Be Vietnam Pro" pitchFamily="34" charset="-122"/>
                 <a:cs typeface="Be Vietnam Pro" pitchFamily="34" charset="-120"/>
               </a:rPr>
-              <a:t> công</a:t>
-            </a:r>
-            <a:r>
-              <a:rPr lang="en-US" sz="1950" dirty="0" spc="-6" kern="0">
+              <a:t> bố</a:t>
+            </a:r>
+            <a:r>
+              <a:rPr lang="en-US" sz="1800" dirty="0" spc="0" kern="0">
                 <a:solidFill>
                   <a:srgbClr val="6B6A66"/>
                 </a:solidFill>
@@ -20548,10 +20592,10 @@
                 <a:ea typeface="Be Vietnam Pro" pitchFamily="34" charset="-122"/>
                 <a:cs typeface="Be Vietnam Pro" pitchFamily="34" charset="-120"/>
               </a:rPr>
-              <a:t> bố</a:t>
-            </a:r>
-            <a:r>
-              <a:rPr lang="en-US" sz="1950" dirty="0" spc="1" kern="0">
+              <a:t> RPM.</a:t>
+            </a:r>
+            <a:r>
+              <a:rPr lang="en-US" sz="1800" dirty="0" spc="2" kern="0">
                 <a:solidFill>
                   <a:srgbClr val="6B6A66"/>
                 </a:solidFill>
@@ -20559,9 +20603,119 @@
                 <a:ea typeface="Be Vietnam Pro" pitchFamily="34" charset="-122"/>
                 <a:cs typeface="Be Vietnam Pro" pitchFamily="34" charset="-120"/>
               </a:rPr>
-              <a:t> RPM.</a:t>
-            </a:r>
-            <a:endParaRPr lang="en-US" sz="1950" dirty="0"/>
+              <a:t> Shorts: các</a:t>
+            </a:r>
+            <a:r>
+              <a:rPr lang="en-US" sz="1800" dirty="0" spc="-4" kern="0">
+                <a:solidFill>
+                  <a:srgbClr val="6B6A66"/>
+                </a:solidFill>
+                <a:latin typeface="Be Vietnam Pro" pitchFamily="34" charset="0"/>
+                <a:ea typeface="Be Vietnam Pro" pitchFamily="34" charset="-122"/>
+                <a:cs typeface="Be Vietnam Pro" pitchFamily="34" charset="-120"/>
+              </a:rPr>
+              <a:t> nguồn</a:t>
+            </a:r>
+            <a:r>
+              <a:rPr lang="en-US" sz="1800" dirty="0" spc="-3" kern="0">
+                <a:solidFill>
+                  <a:srgbClr val="6B6A66"/>
+                </a:solidFill>
+                <a:latin typeface="Be Vietnam Pro" pitchFamily="34" charset="0"/>
+                <a:ea typeface="Be Vietnam Pro" pitchFamily="34" charset="-122"/>
+                <a:cs typeface="Be Vietnam Pro" pitchFamily="34" charset="-120"/>
+              </a:rPr>
+              <a:t> nêu</a:t>
+            </a:r>
+            <a:r>
+              <a:rPr lang="en-US" sz="1800" dirty="0" spc="-2" kern="0">
+                <a:solidFill>
+                  <a:srgbClr val="6B6A66"/>
+                </a:solidFill>
+                <a:latin typeface="Be Vietnam Pro" pitchFamily="34" charset="0"/>
+                <a:ea typeface="Be Vietnam Pro" pitchFamily="34" charset="-122"/>
+                <a:cs typeface="Be Vietnam Pro" pitchFamily="34" charset="-120"/>
+              </a:rPr>
+              <a:t> khoảng</a:t>
+            </a:r>
+            <a:r>
+              <a:rPr lang="en-US" sz="1800" dirty="0" spc="1" kern="0">
+                <a:solidFill>
+                  <a:srgbClr val="6B6A66"/>
+                </a:solidFill>
+                <a:latin typeface="Be Vietnam Pro" pitchFamily="34" charset="0"/>
+                <a:ea typeface="Be Vietnam Pro" pitchFamily="34" charset="-122"/>
+                <a:cs typeface="Be Vietnam Pro" pitchFamily="34" charset="-120"/>
+              </a:rPr>
+              <a:t> khác</a:t>
+            </a:r>
+            <a:r>
+              <a:rPr lang="en-US" sz="1800" dirty="0" spc="-1" kern="0">
+                <a:solidFill>
+                  <a:srgbClr val="6B6A66"/>
+                </a:solidFill>
+                <a:latin typeface="Be Vietnam Pro" pitchFamily="34" charset="0"/>
+                <a:ea typeface="Be Vietnam Pro" pitchFamily="34" charset="-122"/>
+                <a:cs typeface="Be Vietnam Pro" pitchFamily="34" charset="-120"/>
+              </a:rPr>
+              <a:t> nhau.</a:t>
+            </a:r>
+            <a:r>
+              <a:rPr lang="en-US" sz="1800" dirty="0" spc="-6" kern="0">
+                <a:solidFill>
+                  <a:srgbClr val="6B6A66"/>
+                </a:solidFill>
+                <a:latin typeface="Be Vietnam Pro" pitchFamily="34" charset="0"/>
+                <a:ea typeface="Be Vietnam Pro" pitchFamily="34" charset="-122"/>
+                <a:cs typeface="Be Vietnam Pro" pitchFamily="34" charset="-120"/>
+              </a:rPr>
+              <a:t> Việt</a:t>
+            </a:r>
+            <a:r>
+              <a:rPr lang="en-US" sz="1800" dirty="0" spc="2" kern="0">
+                <a:solidFill>
+                  <a:srgbClr val="6B6A66"/>
+                </a:solidFill>
+                <a:latin typeface="Be Vietnam Pro" pitchFamily="34" charset="0"/>
+                <a:ea typeface="Be Vietnam Pro" pitchFamily="34" charset="-122"/>
+                <a:cs typeface="Be Vietnam Pro" pitchFamily="34" charset="-120"/>
+              </a:rPr>
+              <a:t> Nam: hai</a:t>
+            </a:r>
+            <a:r>
+              <a:rPr lang="en-US" sz="1800" dirty="0" spc="-4" kern="0">
+                <a:solidFill>
+                  <a:srgbClr val="6B6A66"/>
+                </a:solidFill>
+                <a:latin typeface="Be Vietnam Pro" pitchFamily="34" charset="0"/>
+                <a:ea typeface="Be Vietnam Pro" pitchFamily="34" charset="-122"/>
+                <a:cs typeface="Be Vietnam Pro" pitchFamily="34" charset="-120"/>
+              </a:rPr>
+              <a:t> bản</a:t>
+            </a:r>
+            <a:r>
+              <a:rPr lang="en-US" sz="1800" dirty="0" spc="-5" kern="0">
+                <a:solidFill>
+                  <a:srgbClr val="6B6A66"/>
+                </a:solidFill>
+                <a:latin typeface="Be Vietnam Pro" pitchFamily="34" charset="0"/>
+                <a:ea typeface="Be Vietnam Pro" pitchFamily="34" charset="-122"/>
+                <a:cs typeface="Be Vietnam Pro" pitchFamily="34" charset="-120"/>
+              </a:rPr>
+              <a:t> số</a:t>
+            </a:r>
+            <a:r>
+              <a:rPr lang="en-US" sz="1800" dirty="0" spc="-2" kern="0">
+                <a:solidFill>
+                  <a:srgbClr val="6B6A66"/>
+                </a:solidFill>
+                <a:latin typeface="Be Vietnam Pro" pitchFamily="34" charset="0"/>
+                <a:ea typeface="Be Vietnam Pro" pitchFamily="34" charset="-122"/>
+                <a:cs typeface="Be Vietnam Pro" pitchFamily="34" charset="-120"/>
+              </a:rPr>
+              <a:t> liệu.</a:t>
+            </a:r>
+            <a:endParaRPr lang="en-US" sz="1800" dirty="0"/>
           </a:p>
         </p:txBody>
       </p:sp>
@@ -21594,7 +21748,7 @@
               <a:buNone/>
             </a:pPr>
             <a:r>
-              <a:rPr lang="en-US" sz="3450" dirty="0" spc="-2" kern="0">
+              <a:rPr lang="en-US" sz="3450" dirty="0" spc="-5" kern="0">
                 <a:solidFill>
                   <a:srgbClr val="FF6A4D"/>
                 </a:solidFill>
@@ -21602,7 +21756,18 @@
                 <a:ea typeface="Bricolage Grotesque ExtraBold" pitchFamily="34" charset="-122"/>
                 <a:cs typeface="Bricolage Grotesque ExtraBold" pitchFamily="34" charset="-120"/>
               </a:rPr>
-              <a:t>khoảng</a:t>
+              <a:t>180</a:t>
+            </a:r>
+            <a:r>
+              <a:rPr lang="en-US" sz="3450" dirty="0" spc="9" kern="0">
+                <a:solidFill>
+                  <a:srgbClr val="FF6A4D"/>
+                </a:solidFill>
+                <a:latin typeface="Bricolage Grotesque ExtraBold" pitchFamily="34" charset="0"/>
+                <a:ea typeface="Bricolage Grotesque ExtraBold" pitchFamily="34" charset="-122"/>
+                <a:cs typeface="Bricolage Grotesque ExtraBold" pitchFamily="34" charset="-120"/>
+              </a:rPr>
+              <a:t> đến</a:t>
             </a:r>
             <a:r>
               <a:rPr lang="en-US" sz="3450" dirty="0" spc="3" kern="0">
@@ -21741,7 +21906,7 @@
               <a:t> đến</a:t>
             </a:r>
             <a:r>
-              <a:rPr lang="en-US" sz="3450" dirty="0" spc="0" kern="0">
+              <a:rPr lang="en-US" sz="3450" dirty="0" spc="-1" kern="0">
                 <a:solidFill>
                   <a:srgbClr val="FF6A4D"/>
                 </a:solidFill>
@@ -21749,7 +21914,7 @@
                 <a:ea typeface="Bricolage Grotesque ExtraBold" pitchFamily="34" charset="-122"/>
                 <a:cs typeface="Bricolage Grotesque ExtraBold" pitchFamily="34" charset="-120"/>
               </a:rPr>
-              <a:t> 100</a:t>
+              <a:t> 200</a:t>
             </a:r>
             <a:r>
               <a:rPr lang="en-US" sz="3450" dirty="0" spc="3" kern="0">

</xml_diff>

<commit_message>
State the current YouTube upload-visibility rule instead of an open conflict
The report and slides 11-12 treated the unverified-API-project rule as two
contradictory Google passages needing a test upload. The live videos.insert
reference says videos from unverified API projects are not restricted to
private viewing mode, and the revision history has no later entry repeating
the 28 July 2020 restriction. Report the live reference as the current rule,
keep the 2020 entry as history only, and drop the open item (slide 12 now
lists the TikTok Creator Rewards AI question instead).

Co-Authored-By: Claude Sonnet 5.5 <noreply@anthropic.com>
Claude-Session: https://claude.ai/code/session_018uW6gkgn9CUzNGw4ERV2G7
</commit_message>
<xml_diff>
--- a/research/xu-huong-kiem-tien-youtube-tiktok-facebook.pptx
+++ b/research/xu-huong-kiem-tien-youtube-tiktok-facebook.pptx
@@ -5286,6 +5286,61 @@
               <a:t> verify:</a:t>
             </a:r>
             <a:r>
+              <a:rPr lang="en-US" sz="2550" dirty="0" spc="1" kern="0">
+                <a:solidFill>
+                  <a:srgbClr val="14161C"/>
+                </a:solidFill>
+                <a:latin typeface="Be Vietnam Pro" pitchFamily="34" charset="0"/>
+                <a:ea typeface="Be Vietnam Pro" pitchFamily="34" charset="-122"/>
+                <a:cs typeface="Be Vietnam Pro" pitchFamily="34" charset="-120"/>
+              </a:rPr>
+              <a:t> không</a:t>
+            </a:r>
+            <a:r>
+              <a:rPr lang="en-US" sz="2550" dirty="0" spc="0" kern="0">
+                <a:solidFill>
+                  <a:srgbClr val="14161C"/>
+                </a:solidFill>
+                <a:latin typeface="Be Vietnam Pro" pitchFamily="34" charset="0"/>
+                <a:ea typeface="Be Vietnam Pro" pitchFamily="34" charset="-122"/>
+                <a:cs typeface="Be Vietnam Pro" pitchFamily="34" charset="-120"/>
+              </a:rPr>
+              <a:t> bị</a:t>
+            </a:r>
+            <a:r>
+              <a:rPr lang="en-US" sz="2550" dirty="0" spc="-2" kern="0">
+                <a:solidFill>
+                  <a:srgbClr val="14161C"/>
+                </a:solidFill>
+                <a:latin typeface="Be Vietnam Pro" pitchFamily="34" charset="0"/>
+                <a:ea typeface="Be Vietnam Pro" pitchFamily="34" charset="-122"/>
+                <a:cs typeface="Be Vietnam Pro" pitchFamily="34" charset="-120"/>
+              </a:rPr>
+              <a:t> khóa</a:t>
+            </a:r>
+            <a:r>
+              <a:rPr lang="en-US" sz="2550" dirty="0" spc="8" kern="0">
+                <a:solidFill>
+                  <a:srgbClr val="14161C"/>
+                </a:solidFill>
+                <a:latin typeface="Be Vietnam Pro" pitchFamily="34" charset="0"/>
+                <a:ea typeface="Be Vietnam Pro" pitchFamily="34" charset="-122"/>
+                <a:cs typeface="Be Vietnam Pro" pitchFamily="34" charset="-120"/>
+              </a:rPr>
+              <a:t> riêng</a:t>
+            </a:r>
+            <a:r>
+              <a:rPr lang="en-US" sz="2550" dirty="0" spc="0" kern="0">
+                <a:solidFill>
+                  <a:srgbClr val="14161C"/>
+                </a:solidFill>
+                <a:latin typeface="Be Vietnam Pro" pitchFamily="34" charset="0"/>
+                <a:ea typeface="Be Vietnam Pro" pitchFamily="34" charset="-122"/>
+                <a:cs typeface="Be Vietnam Pro" pitchFamily="34" charset="-120"/>
+              </a:rPr>
+              <a:t> tư</a:t>
+            </a:r>
+            <a:r>
               <a:rPr lang="en-US" sz="2550" dirty="0" spc="-11" kern="0">
                 <a:solidFill>
                   <a:srgbClr val="14161C"/>
@@ -5294,10 +5349,10 @@
                 <a:ea typeface="Be Vietnam Pro" pitchFamily="34" charset="-122"/>
                 <a:cs typeface="Be Vietnam Pro" pitchFamily="34" charset="-120"/>
               </a:rPr>
-              <a:t> tài</a:t>
-            </a:r>
-            <a:r>
-              <a:rPr lang="en-US" sz="2550" dirty="0" spc="1" kern="0">
+              <a:t> (tài</a:t>
+            </a:r>
+            <a:r>
+              <a:rPr lang="en-US" sz="2550" dirty="0" spc="2" kern="0">
                 <a:solidFill>
                   <a:srgbClr val="14161C"/>
                 </a:solidFill>
@@ -5308,39 +5363,6 @@
               <a:t> liệu</a:t>
             </a:r>
             <a:r>
-              <a:rPr lang="en-US" sz="2550" dirty="0" spc="3" kern="0">
-                <a:solidFill>
-                  <a:srgbClr val="14161C"/>
-                </a:solidFill>
-                <a:latin typeface="Be Vietnam Pro" pitchFamily="34" charset="0"/>
-                <a:ea typeface="Be Vietnam Pro" pitchFamily="34" charset="-122"/>
-                <a:cs typeface="Be Vietnam Pro" pitchFamily="34" charset="-120"/>
-              </a:rPr>
-              <a:t> mâu</a:t>
-            </a:r>
-            <a:r>
-              <a:rPr lang="en-US" sz="2550" dirty="0" spc="1" kern="0">
-                <a:solidFill>
-                  <a:srgbClr val="14161C"/>
-                </a:solidFill>
-                <a:latin typeface="Be Vietnam Pro" pitchFamily="34" charset="0"/>
-                <a:ea typeface="Be Vietnam Pro" pitchFamily="34" charset="-122"/>
-                <a:cs typeface="Be Vietnam Pro" pitchFamily="34" charset="-120"/>
-              </a:rPr>
-              <a:t> thuẫn,</a:t>
-            </a:r>
-            <a:r>
-              <a:rPr lang="en-US" sz="2550" dirty="0" spc="0" kern="0">
-                <a:solidFill>
-                  <a:srgbClr val="14161C"/>
-                </a:solidFill>
-                <a:latin typeface="Be Vietnam Pro" pitchFamily="34" charset="0"/>
-                <a:ea typeface="Be Vietnam Pro" pitchFamily="34" charset="-122"/>
-                <a:cs typeface="Be Vietnam Pro" pitchFamily="34" charset="-120"/>
-              </a:rPr>
-              <a:t> cần</a:t>
-            </a:r>
-            <a:r>
               <a:rPr lang="en-US" sz="2550" dirty="0" spc="-1" kern="0">
                 <a:solidFill>
                   <a:srgbClr val="14161C"/>
@@ -5349,7 +5371,7 @@
                 <a:ea typeface="Be Vietnam Pro" pitchFamily="34" charset="-122"/>
                 <a:cs typeface="Be Vietnam Pro" pitchFamily="34" charset="-120"/>
               </a:rPr>
-              <a:t> thử</a:t>
+              <a:t> hiện hành)</a:t>
             </a:r>
             <a:endParaRPr lang="en-US" sz="2550" dirty="0"/>
           </a:p>
@@ -7384,7 +7406,7 @@
               <a:buChar char="•"/>
             </a:pPr>
             <a:r>
-              <a:rPr lang="en-US" sz="2700" dirty="0" spc="-1" kern="0">
+              <a:rPr lang="en-US" sz="2700" dirty="0" spc="-33" kern="0">
                 <a:solidFill>
                   <a:srgbClr val="E4E1D8"/>
                 </a:solidFill>
@@ -7392,10 +7414,10 @@
                 <a:ea typeface="Be Vietnam Pro" pitchFamily="34" charset="-122"/>
                 <a:cs typeface="Be Vietnam Pro" pitchFamily="34" charset="-120"/>
               </a:rPr>
-              <a:t>API</a:t>
-            </a:r>
-            <a:r>
-              <a:rPr lang="en-US" sz="2700" dirty="0" spc="-69" kern="0">
+              <a:t>Creator</a:t>
+            </a:r>
+            <a:r>
+              <a:rPr lang="en-US" sz="2700" dirty="0" spc="-40" kern="0">
                 <a:solidFill>
                   <a:srgbClr val="E4E1D8"/>
                 </a:solidFill>
@@ -7403,10 +7425,10 @@
                 <a:ea typeface="Be Vietnam Pro" pitchFamily="34" charset="-122"/>
                 <a:cs typeface="Be Vietnam Pro" pitchFamily="34" charset="-120"/>
               </a:rPr>
-              <a:t> YouTube</a:t>
-            </a:r>
-            <a:r>
-              <a:rPr lang="en-US" sz="2700" dirty="0" spc="8" kern="0">
+              <a:t> Rewards:</a:t>
+            </a:r>
+            <a:r>
+              <a:rPr lang="en-US" sz="2700" dirty="0" spc="-3" kern="0">
                 <a:solidFill>
                   <a:srgbClr val="E4E1D8"/>
                 </a:solidFill>
@@ -7414,10 +7436,10 @@
                 <a:ea typeface="Be Vietnam Pro" pitchFamily="34" charset="-122"/>
                 <a:cs typeface="Be Vietnam Pro" pitchFamily="34" charset="-120"/>
               </a:rPr>
-              <a:t> chưa</a:t>
-            </a:r>
-            <a:r>
-              <a:rPr lang="en-US" sz="2700" dirty="0" spc="1" kern="0">
+              <a:t> video</a:t>
+            </a:r>
+            <a:r>
+              <a:rPr lang="en-US" sz="2700" dirty="0" spc="-14" kern="0">
                 <a:solidFill>
                   <a:srgbClr val="E4E1D8"/>
                 </a:solidFill>
@@ -7425,10 +7447,10 @@
                 <a:ea typeface="Be Vietnam Pro" pitchFamily="34" charset="-122"/>
                 <a:cs typeface="Be Vietnam Pro" pitchFamily="34" charset="-120"/>
               </a:rPr>
-              <a:t> verify:</a:t>
-            </a:r>
-            <a:r>
-              <a:rPr lang="en-US" sz="2700" dirty="0" spc="-2" kern="0">
+              <a:t> toàn</a:t>
+            </a:r>
+            <a:r>
+              <a:rPr lang="en-US" sz="2700" dirty="0" spc="-3" kern="0">
                 <a:solidFill>
                   <a:srgbClr val="E4E1D8"/>
                 </a:solidFill>
@@ -7436,10 +7458,10 @@
                 <a:ea typeface="Be Vietnam Pro" pitchFamily="34" charset="-122"/>
                 <a:cs typeface="Be Vietnam Pro" pitchFamily="34" charset="-120"/>
               </a:rPr>
-              <a:t> thử</a:t>
-            </a:r>
-            <a:r>
-              <a:rPr lang="en-US" sz="2700" dirty="0" spc="-7" kern="0">
+              <a:t> AI</a:t>
+            </a:r>
+            <a:r>
+              <a:rPr lang="en-US" sz="2700" dirty="0" spc="0" kern="0">
                 <a:solidFill>
                   <a:srgbClr val="E4E1D8"/>
                 </a:solidFill>
@@ -7447,10 +7469,10 @@
                 <a:ea typeface="Be Vietnam Pro" pitchFamily="34" charset="-122"/>
                 <a:cs typeface="Be Vietnam Pro" pitchFamily="34" charset="-120"/>
               </a:rPr>
-              <a:t> một</a:t>
-            </a:r>
-            <a:r>
-              <a:rPr lang="en-US" sz="2700" dirty="0" spc="-2" kern="0">
+              <a:t> có</a:t>
+            </a:r>
+            <a:r>
+              <a:rPr lang="en-US" sz="2700" dirty="0" spc="-3" kern="0">
                 <a:solidFill>
                   <a:srgbClr val="E4E1D8"/>
                 </a:solidFill>
@@ -7458,7 +7480,29 @@
                 <a:ea typeface="Be Vietnam Pro" pitchFamily="34" charset="-122"/>
                 <a:cs typeface="Be Vietnam Pro" pitchFamily="34" charset="-120"/>
               </a:rPr>
-              <a:t> video</a:t>
+              <a:t> đủ</a:t>
+            </a:r>
+            <a:r>
+              <a:rPr lang="en-US" sz="2700" dirty="0" spc="20" kern="0">
+                <a:solidFill>
+                  <a:srgbClr val="E4E1D8"/>
+                </a:solidFill>
+                <a:latin typeface="Be Vietnam Pro" pitchFamily="34" charset="0"/>
+                <a:ea typeface="Be Vietnam Pro" pitchFamily="34" charset="-122"/>
+                <a:cs typeface="Be Vietnam Pro" pitchFamily="34" charset="-120"/>
+              </a:rPr>
+              <a:t> điều</a:t>
+            </a:r>
+            <a:r>
+              <a:rPr lang="en-US" sz="2700" dirty="0" spc="-3" kern="0">
+                <a:solidFill>
+                  <a:srgbClr val="E4E1D8"/>
+                </a:solidFill>
+                <a:latin typeface="Be Vietnam Pro" pitchFamily="34" charset="0"/>
+                <a:ea typeface="Be Vietnam Pro" pitchFamily="34" charset="-122"/>
+                <a:cs typeface="Be Vietnam Pro" pitchFamily="34" charset="-120"/>
+              </a:rPr>
+              <a:t> kiện?</a:t>
             </a:r>
             <a:endParaRPr lang="en-US" sz="2700" dirty="0"/>
           </a:p>

</xml_diff>

<commit_message>
Document the manual route to public posts for unaudited TikTok clients
The report said unaudited Direct Post clients stay private and the advice
treated Inbox Upload as the only way to a public post. The Content Sharing
Guidelines say the account owner can make the account public and then change
each post to "Everyone". State that route (it costs work per post, so it only
suits a few posts), keep Inbox Upload and the TikTok web scheduler as the
other options, and say the audit's intended-use rule excludes tools that only
post to your own accounts instead of calling it a refusal. Slide 11 follows.

Co-Authored-By: Claude Sonnet 5.5 <noreply@anthropic.com>
Claude-Session: https://claude.ai/code/session_018uW6gkgn9CUzNGw4ERV2G7
</commit_message>
<xml_diff>
--- a/research/xu-huong-kiem-tien-youtube-tiktok-facebook.pptx
+++ b/research/xu-huong-kiem-tien-youtube-tiktok-facebook.pptx
@@ -5498,6 +5498,94 @@
               <a:t> audit:</a:t>
             </a:r>
             <a:r>
+              <a:rPr lang="en-US" sz="2550" dirty="0" spc="10" kern="0">
+                <a:solidFill>
+                  <a:srgbClr val="14161C"/>
+                </a:solidFill>
+                <a:latin typeface="Be Vietnam Pro" pitchFamily="34" charset="0"/>
+                <a:ea typeface="Be Vietnam Pro" pitchFamily="34" charset="-122"/>
+                <a:cs typeface="Be Vietnam Pro" pitchFamily="34" charset="-120"/>
+              </a:rPr>
+              <a:t> đăng</a:t>
+            </a:r>
+            <a:r>
+              <a:rPr lang="en-US" sz="2550" dirty="0" spc="9" kern="0">
+                <a:solidFill>
+                  <a:srgbClr val="14161C"/>
+                </a:solidFill>
+                <a:latin typeface="Be Vietnam Pro" pitchFamily="34" charset="0"/>
+                <a:ea typeface="Be Vietnam Pro" pitchFamily="34" charset="-122"/>
+                <a:cs typeface="Be Vietnam Pro" pitchFamily="34" charset="-120"/>
+              </a:rPr>
+              <a:t> riêng</a:t>
+            </a:r>
+            <a:r>
+              <a:rPr lang="en-US" sz="2550" dirty="0" spc="-2" kern="0">
+                <a:solidFill>
+                  <a:srgbClr val="14161C"/>
+                </a:solidFill>
+                <a:latin typeface="Be Vietnam Pro" pitchFamily="34" charset="0"/>
+                <a:ea typeface="Be Vietnam Pro" pitchFamily="34" charset="-122"/>
+                <a:cs typeface="Be Vietnam Pro" pitchFamily="34" charset="-120"/>
+              </a:rPr>
+              <a:t> tư,</a:t>
+            </a:r>
+            <a:r>
+              <a:rPr lang="en-US" sz="2550" dirty="0" spc="-1" kern="0">
+                <a:solidFill>
+                  <a:srgbClr val="14161C"/>
+                </a:solidFill>
+                <a:latin typeface="Be Vietnam Pro" pitchFamily="34" charset="0"/>
+                <a:ea typeface="Be Vietnam Pro" pitchFamily="34" charset="-122"/>
+                <a:cs typeface="Be Vietnam Pro" pitchFamily="34" charset="-120"/>
+              </a:rPr>
+              <a:t> tự</a:t>
+            </a:r>
+            <a:r>
+              <a:rPr lang="en-US" sz="2550" dirty="0" spc="13" kern="0">
+                <a:solidFill>
+                  <a:srgbClr val="14161C"/>
+                </a:solidFill>
+                <a:latin typeface="Be Vietnam Pro" pitchFamily="34" charset="0"/>
+                <a:ea typeface="Be Vietnam Pro" pitchFamily="34" charset="-122"/>
+                <a:cs typeface="Be Vietnam Pro" pitchFamily="34" charset="-120"/>
+              </a:rPr>
+              <a:t> đổi</a:t>
+            </a:r>
+            <a:r>
+              <a:rPr lang="en-US" sz="2550" dirty="0" spc="20" kern="0">
+                <a:solidFill>
+                  <a:srgbClr val="14161C"/>
+                </a:solidFill>
+                <a:latin typeface="Be Vietnam Pro" pitchFamily="34" charset="0"/>
+                <a:ea typeface="Be Vietnam Pro" pitchFamily="34" charset="-122"/>
+                <a:cs typeface="Be Vietnam Pro" pitchFamily="34" charset="-120"/>
+              </a:rPr>
+              <a:t> từng</a:t>
+            </a:r>
+            <a:r>
+              <a:rPr lang="en-US" sz="2550" dirty="0" spc="-4" kern="0">
+                <a:solidFill>
+                  <a:srgbClr val="14161C"/>
+                </a:solidFill>
+                <a:latin typeface="Be Vietnam Pro" pitchFamily="34" charset="0"/>
+                <a:ea typeface="Be Vietnam Pro" pitchFamily="34" charset="-122"/>
+                <a:cs typeface="Be Vietnam Pro" pitchFamily="34" charset="-120"/>
+              </a:rPr>
+              <a:t> bài</a:t>
+            </a:r>
+            <a:r>
+              <a:rPr lang="en-US" sz="2550" dirty="0" spc="-6" kern="0">
+                <a:solidFill>
+                  <a:srgbClr val="14161C"/>
+                </a:solidFill>
+                <a:latin typeface="Be Vietnam Pro" pitchFamily="34" charset="0"/>
+                <a:ea typeface="Be Vietnam Pro" pitchFamily="34" charset="-122"/>
+                <a:cs typeface="Be Vietnam Pro" pitchFamily="34" charset="-120"/>
+              </a:rPr>
+              <a:t> sang</a:t>
+            </a:r>
+            <a:r>
               <a:rPr lang="en-US" sz="2550" dirty="0" spc="0" kern="0">
                 <a:solidFill>
                   <a:srgbClr val="14161C"/>
@@ -5506,73 +5594,7 @@
                 <a:ea typeface="Be Vietnam Pro" pitchFamily="34" charset="-122"/>
                 <a:cs typeface="Be Vietnam Pro" pitchFamily="34" charset="-120"/>
               </a:rPr>
-              <a:t> chỉ</a:t>
-            </a:r>
-            <a:r>
-              <a:rPr lang="en-US" sz="2550" dirty="0" spc="11" kern="0">
-                <a:solidFill>
-                  <a:srgbClr val="14161C"/>
-                </a:solidFill>
-                <a:latin typeface="Be Vietnam Pro" pitchFamily="34" charset="0"/>
-                <a:ea typeface="Be Vietnam Pro" pitchFamily="34" charset="-122"/>
-                <a:cs typeface="Be Vietnam Pro" pitchFamily="34" charset="-120"/>
-              </a:rPr>
-              <a:t> đăng</a:t>
-            </a:r>
-            <a:r>
-              <a:rPr lang="en-US" sz="2550" dirty="0" spc="-1" kern="0">
-                <a:solidFill>
-                  <a:srgbClr val="14161C"/>
-                </a:solidFill>
-                <a:latin typeface="Be Vietnam Pro" pitchFamily="34" charset="0"/>
-                <a:ea typeface="Be Vietnam Pro" pitchFamily="34" charset="-122"/>
-                <a:cs typeface="Be Vietnam Pro" pitchFamily="34" charset="-120"/>
-              </a:rPr>
-              <a:t> ở</a:t>
-            </a:r>
-            <a:r>
-              <a:rPr lang="en-US" sz="2550" dirty="0" spc="0" kern="0">
-                <a:solidFill>
-                  <a:srgbClr val="14161C"/>
-                </a:solidFill>
-                <a:latin typeface="Be Vietnam Pro" pitchFamily="34" charset="0"/>
-                <a:ea typeface="Be Vietnam Pro" pitchFamily="34" charset="-122"/>
-                <a:cs typeface="Be Vietnam Pro" pitchFamily="34" charset="-120"/>
-              </a:rPr>
-              <a:t> chế</a:t>
-            </a:r>
-            <a:r>
-              <a:rPr lang="en-US" sz="2550" dirty="0" spc="17" kern="0">
-                <a:solidFill>
-                  <a:srgbClr val="14161C"/>
-                </a:solidFill>
-                <a:latin typeface="Be Vietnam Pro" pitchFamily="34" charset="0"/>
-                <a:ea typeface="Be Vietnam Pro" pitchFamily="34" charset="-122"/>
-                <a:cs typeface="Be Vietnam Pro" pitchFamily="34" charset="-120"/>
-              </a:rPr>
-              <a:t> độ</a:t>
-            </a:r>
-            <a:r>
-              <a:rPr lang="en-US" sz="2550" dirty="0" spc="9" kern="0">
-                <a:solidFill>
-                  <a:srgbClr val="14161C"/>
-                </a:solidFill>
-                <a:latin typeface="Be Vietnam Pro" pitchFamily="34" charset="0"/>
-                <a:ea typeface="Be Vietnam Pro" pitchFamily="34" charset="-122"/>
-                <a:cs typeface="Be Vietnam Pro" pitchFamily="34" charset="-120"/>
-              </a:rPr>
-              <a:t> riêng</a:t>
-            </a:r>
-            <a:r>
-              <a:rPr lang="en-US" sz="2550" dirty="0" spc="-2" kern="0">
-                <a:solidFill>
-                  <a:srgbClr val="14161C"/>
-                </a:solidFill>
-                <a:latin typeface="Be Vietnam Pro" pitchFamily="34" charset="0"/>
-                <a:ea typeface="Be Vietnam Pro" pitchFamily="34" charset="-122"/>
-                <a:cs typeface="Be Vietnam Pro" pitchFamily="34" charset="-120"/>
-              </a:rPr>
-              <a:t> tư</a:t>
+              <a:t> công khai</a:t>
             </a:r>
             <a:endParaRPr lang="en-US" sz="2550" dirty="0"/>
           </a:p>
@@ -5688,26 +5710,15 @@
               <a:buChar char="•"/>
             </a:pPr>
             <a:r>
-              <a:rPr lang="en-US" sz="2550" dirty="0" spc="-11" kern="0">
-                <a:solidFill>
-                  <a:srgbClr val="14161C"/>
-                </a:solidFill>
-                <a:latin typeface="Be Vietnam Pro" pitchFamily="34" charset="0"/>
-                <a:ea typeface="Be Vietnam Pro" pitchFamily="34" charset="-122"/>
-                <a:cs typeface="Be Vietnam Pro" pitchFamily="34" charset="-120"/>
-              </a:rPr>
-              <a:t>Thay</a:t>
-            </a:r>
-            <a:r>
-              <a:rPr lang="en-US" sz="2550" dirty="0" spc="2" kern="0">
-                <a:solidFill>
-                  <a:srgbClr val="14161C"/>
-                </a:solidFill>
-                <a:latin typeface="Be Vietnam Pro" pitchFamily="34" charset="0"/>
-                <a:ea typeface="Be Vietnam Pro" pitchFamily="34" charset="-122"/>
-                <a:cs typeface="Be Vietnam Pro" pitchFamily="34" charset="-120"/>
-              </a:rPr>
-              <a:t> thế:</a:t>
+              <a:rPr lang="en-US" sz="2550" dirty="0" spc="1" kern="0">
+                <a:solidFill>
+                  <a:srgbClr val="14161C"/>
+                </a:solidFill>
+                <a:latin typeface="Be Vietnam Pro" pitchFamily="34" charset="0"/>
+                <a:ea typeface="Be Vietnam Pro" pitchFamily="34" charset="-122"/>
+                <a:cs typeface="Be Vietnam Pro" pitchFamily="34" charset="-120"/>
+              </a:rPr>
+              <a:t>Cách khác:</a:t>
             </a:r>
             <a:r>
               <a:rPr lang="en-US" sz="2550" dirty="0" spc="-2" kern="0">
@@ -5721,6 +5732,17 @@
               <a:t> Upload</a:t>
             </a:r>
             <a:r>
+              <a:rPr lang="en-US" sz="2550" dirty="0" spc="0" kern="0">
+                <a:solidFill>
+                  <a:srgbClr val="14161C"/>
+                </a:solidFill>
+                <a:latin typeface="Be Vietnam Pro" pitchFamily="34" charset="0"/>
+                <a:ea typeface="Be Vietnam Pro" pitchFamily="34" charset="-122"/>
+                <a:cs typeface="Be Vietnam Pro" pitchFamily="34" charset="-120"/>
+              </a:rPr>
+              <a:t> hộp</a:t>
+            </a:r>
+            <a:r>
               <a:rPr lang="en-US" sz="2550" dirty="0" spc="-1" kern="0">
                 <a:solidFill>
                   <a:srgbClr val="14161C"/>
@@ -5729,32 +5751,10 @@
                 <a:ea typeface="Be Vietnam Pro" pitchFamily="34" charset="-122"/>
                 <a:cs typeface="Be Vietnam Pro" pitchFamily="34" charset="-120"/>
               </a:rPr>
-              <a:t> hộp</a:t>
-            </a:r>
-            <a:r>
-              <a:rPr lang="en-US" sz="2550" dirty="0" spc="-2" kern="0">
-                <a:solidFill>
-                  <a:srgbClr val="14161C"/>
-                </a:solidFill>
-                <a:latin typeface="Be Vietnam Pro" pitchFamily="34" charset="0"/>
-                <a:ea typeface="Be Vietnam Pro" pitchFamily="34" charset="-122"/>
-                <a:cs typeface="Be Vietnam Pro" pitchFamily="34" charset="-120"/>
-              </a:rPr>
-              <a:t> thư,</a:t>
-            </a:r>
-            <a:r>
-              <a:rPr lang="en-US" sz="2550" dirty="0" spc="1" kern="0">
-                <a:solidFill>
-                  <a:srgbClr val="14161C"/>
-                </a:solidFill>
-                <a:latin typeface="Be Vietnam Pro" pitchFamily="34" charset="0"/>
-                <a:ea typeface="Be Vietnam Pro" pitchFamily="34" charset="-122"/>
-                <a:cs typeface="Be Vietnam Pro" pitchFamily="34" charset="-120"/>
-              </a:rPr>
-              <a:t> hẹn</a:t>
-            </a:r>
-            <a:r>
-              <a:rPr lang="en-US" sz="2550" dirty="0" spc="-1" kern="0">
+              <a:t> thư, hẹn</a:t>
+            </a:r>
+            <a:r>
+              <a:rPr lang="en-US" sz="2550" dirty="0" spc="0" kern="0">
                 <a:solidFill>
                   <a:srgbClr val="14161C"/>
                 </a:solidFill>

</xml_diff>

<commit_message>
Label the YouTube ads threshold as such and add the 500-subscriber tier
The summary table and slide 5 called 1,000 subscribers plus 4,000 watch hours
(or 10 million Shorts views) the minimum for earning, although the report
already documents the 500-subscriber tier that unlocks fan funding, Creator
Partnerships and Shopping and that the 2027 change leaves as it is. Retitle the
column and slide 5 as the main (ads) threshold, list the early tier next to
each YouTube row, add it to summary item 3, and call the slide 2 figure the
ads threshold.

Co-Authored-By: Claude Sonnet 5.5 <noreply@anthropic.com>
Claude-Session: https://claude.ai/code/session_018uW6gkgn9CUzNGw4ERV2G7
</commit_message>
<xml_diff>
--- a/research/xu-huong-kiem-tien-youtube-tiktok-facebook.pptx
+++ b/research/xu-huong-kiem-tien-youtube-tiktok-facebook.pptx
@@ -9149,21 +9149,10 @@
                 <a:ea typeface="Bricolage Grotesque ExtraBold" pitchFamily="34" charset="-122"/>
                 <a:cs typeface="Bricolage Grotesque ExtraBold" pitchFamily="34" charset="-120"/>
               </a:rPr>
-              <a:t> kiếm</a:t>
-            </a:r>
-            <a:r>
-              <a:rPr lang="en-US" sz="4200" dirty="0" spc="1" kern="0">
-                <a:solidFill>
-                  <a:srgbClr val="14161C"/>
-                </a:solidFill>
-                <a:latin typeface="Bricolage Grotesque ExtraBold" pitchFamily="34" charset="0"/>
-                <a:ea typeface="Bricolage Grotesque ExtraBold" pitchFamily="34" charset="-122"/>
-                <a:cs typeface="Bricolage Grotesque ExtraBold" pitchFamily="34" charset="-120"/>
-              </a:rPr>
-              <a:t> tiền</a:t>
-            </a:r>
-            <a:r>
-              <a:rPr lang="en-US" sz="4200" dirty="0" spc="-17" kern="0">
+              <a:t> quảng cáo</a:t>
+            </a:r>
+            <a:r>
+              <a:rPr lang="en-US" sz="4200" dirty="0" spc="-16" kern="0">
                 <a:solidFill>
                   <a:srgbClr val="14161C"/>
                 </a:solidFill>
@@ -14877,7 +14866,7 @@
               <a:t>Mốc</a:t>
             </a:r>
             <a:r>
-              <a:rPr lang="en-US" sz="7500" dirty="0" spc="-29" kern="0">
+              <a:rPr lang="en-US" sz="7500" dirty="0" spc="-7" kern="0">
                 <a:solidFill>
                   <a:srgbClr val="14161C"/>
                 </a:solidFill>
@@ -14885,10 +14874,10 @@
                 <a:ea typeface="Bricolage Grotesque ExtraBold" pitchFamily="34" charset="-122"/>
                 <a:cs typeface="Bricolage Grotesque ExtraBold" pitchFamily="34" charset="-120"/>
               </a:rPr>
-              <a:t> tối</a:t>
-            </a:r>
-            <a:r>
-              <a:rPr lang="en-US" sz="7500" dirty="0" spc="5" kern="0">
+              <a:t> bật</a:t>
+            </a:r>
+            <a:r>
+              <a:rPr lang="en-US" sz="7500" dirty="0" spc="3" kern="0">
                 <a:solidFill>
                   <a:srgbClr val="14161C"/>
                 </a:solidFill>
@@ -14896,10 +14885,10 @@
                 <a:ea typeface="Bricolage Grotesque ExtraBold" pitchFamily="34" charset="-122"/>
                 <a:cs typeface="Bricolage Grotesque ExtraBold" pitchFamily="34" charset="-120"/>
               </a:rPr>
-              <a:t> thiểu</a:t>
-            </a:r>
-            <a:r>
-              <a:rPr lang="en-US" sz="7500" dirty="0" spc="19" kern="0">
+              <a:t> kiếm</a:t>
+            </a:r>
+            <a:r>
+              <a:rPr lang="en-US" sz="7500" dirty="0" spc="4" kern="0">
                 <a:solidFill>
                   <a:srgbClr val="14161C"/>
                 </a:solidFill>
@@ -14907,7 +14896,7 @@
                 <a:ea typeface="Bricolage Grotesque ExtraBold" pitchFamily="34" charset="-122"/>
                 <a:cs typeface="Bricolage Grotesque ExtraBold" pitchFamily="34" charset="-120"/>
               </a:rPr>
-              <a:t> để</a:t>
+              <a:t> tiền</a:t>
             </a:r>
             <a:r>
               <a:rPr lang="en-US" sz="7500" dirty="0" spc="3" kern="0">
@@ -14918,18 +14907,7 @@
                 <a:ea typeface="Bricolage Grotesque ExtraBold" pitchFamily="34" charset="-122"/>
                 <a:cs typeface="Bricolage Grotesque ExtraBold" pitchFamily="34" charset="-120"/>
               </a:rPr>
-              <a:t> kiếm</a:t>
-            </a:r>
-            <a:r>
-              <a:rPr lang="en-US" sz="7500" dirty="0" spc="4" kern="0">
-                <a:solidFill>
-                  <a:srgbClr val="14161C"/>
-                </a:solidFill>
-                <a:latin typeface="Bricolage Grotesque ExtraBold" pitchFamily="34" charset="0"/>
-                <a:ea typeface="Bricolage Grotesque ExtraBold" pitchFamily="34" charset="-122"/>
-                <a:cs typeface="Bricolage Grotesque ExtraBold" pitchFamily="34" charset="-120"/>
-              </a:rPr>
-              <a:t> tiền</a:t>
+              <a:t> chính</a:t>
             </a:r>
             <a:endParaRPr lang="en-US" sz="7500" dirty="0"/>
           </a:p>
@@ -15050,6 +15028,39 @@
               </a:rPr>
               <a:t> 31/1/2027</a:t>
             </a:r>
+            <a:r>
+              <a:rPr lang="en-US" sz="1950" dirty="0" spc="0" kern="0">
+                <a:solidFill>
+                  <a:srgbClr val="6B6A66"/>
+                </a:solidFill>
+                <a:latin typeface="Be Vietnam Pro" pitchFamily="34" charset="0"/>
+                <a:ea typeface="Be Vietnam Pro" pitchFamily="34" charset="-122"/>
+                <a:cs typeface="Be Vietnam Pro" pitchFamily="34" charset="-120"/>
+              </a:rPr>
+              <a:t> ·</a:t>
+            </a:r>
+            <a:r>
+              <a:rPr lang="en-US" sz="1950" dirty="0" spc="1" kern="0">
+                <a:solidFill>
+                  <a:srgbClr val="6B6A66"/>
+                </a:solidFill>
+                <a:latin typeface="Be Vietnam Pro" pitchFamily="34" charset="0"/>
+                <a:ea typeface="Be Vietnam Pro" pitchFamily="34" charset="-122"/>
+                <a:cs typeface="Be Vietnam Pro" pitchFamily="34" charset="-120"/>
+              </a:rPr>
+              <a:t> quảng</a:t>
+            </a:r>
+            <a:r>
+              <a:rPr lang="en-US" sz="1950" dirty="0" spc="-2" kern="0">
+                <a:solidFill>
+                  <a:srgbClr val="6B6A66"/>
+                </a:solidFill>
+                <a:latin typeface="Be Vietnam Pro" pitchFamily="34" charset="0"/>
+                <a:ea typeface="Be Vietnam Pro" pitchFamily="34" charset="-122"/>
+                <a:cs typeface="Be Vietnam Pro" pitchFamily="34" charset="-120"/>
+              </a:rPr>
+              <a:t> cáo</a:t>
+            </a:r>
             <a:endParaRPr lang="en-US" sz="1950" dirty="0"/>
           </a:p>
         </p:txBody>
@@ -15217,6 +15228,138 @@
               <a:buNone/>
             </a:pPr>
             <a:r>
+              <a:rPr lang="en-US" sz="2100" dirty="0" spc="-2" kern="0">
+                <a:solidFill>
+                  <a:srgbClr val="6B6A66"/>
+                </a:solidFill>
+                <a:latin typeface="Be Vietnam Pro" pitchFamily="34" charset="0"/>
+                <a:ea typeface="Be Vietnam Pro" pitchFamily="34" charset="-122"/>
+                <a:cs typeface="Be Vietnam Pro" pitchFamily="34" charset="-120"/>
+              </a:rPr>
+              <a:t>Cấp</a:t>
+            </a:r>
+            <a:r>
+              <a:rPr lang="en-US" sz="2100" dirty="0" spc="-7" kern="0">
+                <a:solidFill>
+                  <a:srgbClr val="6B6A66"/>
+                </a:solidFill>
+                <a:latin typeface="Be Vietnam Pro" pitchFamily="34" charset="0"/>
+                <a:ea typeface="Be Vietnam Pro" pitchFamily="34" charset="-122"/>
+                <a:cs typeface="Be Vietnam Pro" pitchFamily="34" charset="-120"/>
+              </a:rPr>
+              <a:t> sớm</a:t>
+            </a:r>
+            <a:r>
+              <a:rPr lang="en-US" sz="2100" dirty="0" spc="-4" kern="0">
+                <a:solidFill>
+                  <a:srgbClr val="6B6A66"/>
+                </a:solidFill>
+                <a:latin typeface="Be Vietnam Pro" pitchFamily="34" charset="0"/>
+                <a:ea typeface="Be Vietnam Pro" pitchFamily="34" charset="-122"/>
+                <a:cs typeface="Be Vietnam Pro" pitchFamily="34" charset="-120"/>
+              </a:rPr>
+              <a:t> 500</a:t>
+            </a:r>
+            <a:r>
+              <a:rPr lang="en-US" sz="2100" dirty="0" spc="-1" kern="0">
+                <a:solidFill>
+                  <a:srgbClr val="6B6A66"/>
+                </a:solidFill>
+                <a:latin typeface="Be Vietnam Pro" pitchFamily="34" charset="0"/>
+                <a:ea typeface="Be Vietnam Pro" pitchFamily="34" charset="-122"/>
+                <a:cs typeface="Be Vietnam Pro" pitchFamily="34" charset="-120"/>
+              </a:rPr>
+              <a:t> sub</a:t>
+            </a:r>
+            <a:r>
+              <a:rPr lang="en-US" sz="2100" dirty="0" spc="-2" kern="0">
+                <a:solidFill>
+                  <a:srgbClr val="6B6A66"/>
+                </a:solidFill>
+                <a:latin typeface="Be Vietnam Pro" pitchFamily="34" charset="0"/>
+                <a:ea typeface="Be Vietnam Pro" pitchFamily="34" charset="-122"/>
+                <a:cs typeface="Be Vietnam Pro" pitchFamily="34" charset="-120"/>
+              </a:rPr>
+              <a:t> +</a:t>
+            </a:r>
+            <a:r>
+              <a:rPr lang="en-US" sz="2100" dirty="0" spc="-4" kern="0">
+                <a:solidFill>
+                  <a:srgbClr val="6B6A66"/>
+                </a:solidFill>
+                <a:latin typeface="Be Vietnam Pro" pitchFamily="34" charset="0"/>
+                <a:ea typeface="Be Vietnam Pro" pitchFamily="34" charset="-122"/>
+                <a:cs typeface="Be Vietnam Pro" pitchFamily="34" charset="-120"/>
+              </a:rPr>
+              <a:t> 3.000</a:t>
+            </a:r>
+            <a:r>
+              <a:rPr lang="en-US" sz="2100" dirty="0" spc="-1" kern="0">
+                <a:solidFill>
+                  <a:srgbClr val="6B6A66"/>
+                </a:solidFill>
+                <a:latin typeface="Be Vietnam Pro" pitchFamily="34" charset="0"/>
+                <a:ea typeface="Be Vietnam Pro" pitchFamily="34" charset="-122"/>
+                <a:cs typeface="Be Vietnam Pro" pitchFamily="34" charset="-120"/>
+              </a:rPr>
+              <a:t> giờ</a:t>
+            </a:r>
+            <a:r>
+              <a:rPr lang="en-US" sz="2100" dirty="0" spc="-4" kern="0">
+                <a:solidFill>
+                  <a:srgbClr val="6B6A66"/>
+                </a:solidFill>
+                <a:latin typeface="Be Vietnam Pro" pitchFamily="34" charset="0"/>
+                <a:ea typeface="Be Vietnam Pro" pitchFamily="34" charset="-122"/>
+                <a:cs typeface="Be Vietnam Pro" pitchFamily="34" charset="-120"/>
+              </a:rPr>
+              <a:t> hoặc</a:t>
+            </a:r>
+            <a:r>
+              <a:rPr lang="en-US" sz="2100" dirty="0" spc="-3" kern="0">
+                <a:solidFill>
+                  <a:srgbClr val="6B6A66"/>
+                </a:solidFill>
+                <a:latin typeface="Be Vietnam Pro" pitchFamily="34" charset="0"/>
+                <a:ea typeface="Be Vietnam Pro" pitchFamily="34" charset="-122"/>
+                <a:cs typeface="Be Vietnam Pro" pitchFamily="34" charset="-120"/>
+              </a:rPr>
+              <a:t> 3</a:t>
+            </a:r>
+            <a:r>
+              <a:rPr lang="en-US" sz="2100" dirty="0" spc="7" kern="0">
+                <a:solidFill>
+                  <a:srgbClr val="6B6A66"/>
+                </a:solidFill>
+                <a:latin typeface="Be Vietnam Pro" pitchFamily="34" charset="0"/>
+                <a:ea typeface="Be Vietnam Pro" pitchFamily="34" charset="-122"/>
+                <a:cs typeface="Be Vietnam Pro" pitchFamily="34" charset="-120"/>
+              </a:rPr>
+              <a:t> triệu</a:t>
+            </a:r>
+            <a:r>
+              <a:rPr lang="en-US" sz="2100" dirty="0" spc="-1" kern="0">
+                <a:solidFill>
+                  <a:srgbClr val="6B6A66"/>
+                </a:solidFill>
+                <a:latin typeface="Be Vietnam Pro" pitchFamily="34" charset="0"/>
+                <a:ea typeface="Be Vietnam Pro" pitchFamily="34" charset="-122"/>
+                <a:cs typeface="Be Vietnam Pro" pitchFamily="34" charset="-120"/>
+              </a:rPr>
+              <a:t> Shorts</a:t>
+            </a:r>
+            <a:r>
+              <a:rPr lang="en-US" sz="2100" dirty="0" spc="-4" kern="0">
+                <a:solidFill>
+                  <a:srgbClr val="6B6A66"/>
+                </a:solidFill>
+                <a:latin typeface="Be Vietnam Pro" pitchFamily="34" charset="0"/>
+                <a:ea typeface="Be Vietnam Pro" pitchFamily="34" charset="-122"/>
+                <a:cs typeface="Be Vietnam Pro" pitchFamily="34" charset="-120"/>
+              </a:rPr>
+              <a:t> ·</a:t>
+            </a:r>
+            <a:r>
               <a:rPr lang="en-US" sz="2100" dirty="0" spc="-5" kern="0">
                 <a:solidFill>
                   <a:srgbClr val="6B6A66"/>
@@ -15225,7 +15368,7 @@
                 <a:ea typeface="Be Vietnam Pro" pitchFamily="34" charset="-122"/>
                 <a:cs typeface="Be Vietnam Pro" pitchFamily="34" charset="-120"/>
               </a:rPr>
-              <a:t>Việt</a:t>
+              <a:t> Việt</a:t>
             </a:r>
             <a:r>
               <a:rPr lang="en-US" sz="2100" dirty="0" spc="-1" kern="0">
@@ -15259,39 +15402,6 @@
                 <a:cs typeface="Be Vietnam Pro" pitchFamily="34" charset="-120"/>
               </a:rPr>
               <a:t> trong</a:t>
-            </a:r>
-            <a:r>
-              <a:rPr lang="en-US" sz="2100" dirty="0" spc="-2" kern="0">
-                <a:solidFill>
-                  <a:srgbClr val="6B6A66"/>
-                </a:solidFill>
-                <a:latin typeface="Be Vietnam Pro" pitchFamily="34" charset="0"/>
-                <a:ea typeface="Be Vietnam Pro" pitchFamily="34" charset="-122"/>
-                <a:cs typeface="Be Vietnam Pro" pitchFamily="34" charset="-120"/>
-              </a:rPr>
-              <a:t> danh</a:t>
-            </a:r>
-            <a:r>
-              <a:rPr lang="en-US" sz="2100" dirty="0" spc="-5" kern="0">
-                <a:solidFill>
-                  <a:srgbClr val="6B6A66"/>
-                </a:solidFill>
-                <a:latin typeface="Be Vietnam Pro" pitchFamily="34" charset="0"/>
-                <a:ea typeface="Be Vietnam Pro" pitchFamily="34" charset="-122"/>
-                <a:cs typeface="Be Vietnam Pro" pitchFamily="34" charset="-120"/>
-              </a:rPr>
-              <a:t> sách</a:t>
-            </a:r>
-            <a:r>
-              <a:rPr lang="en-US" sz="2100" dirty="0" spc="4" kern="0">
-                <a:solidFill>
-                  <a:srgbClr val="6B6A66"/>
-                </a:solidFill>
-                <a:latin typeface="Be Vietnam Pro" pitchFamily="34" charset="0"/>
-                <a:ea typeface="Be Vietnam Pro" pitchFamily="34" charset="-122"/>
-                <a:cs typeface="Be Vietnam Pro" pitchFamily="34" charset="-120"/>
-              </a:rPr>
-              <a:t> nước</a:t>
             </a:r>
             <a:r>
               <a:rPr lang="en-US" sz="2100" dirty="0" spc="0" kern="0">
@@ -15423,6 +15533,39 @@
               </a:rPr>
               <a:t> 1/2/2027</a:t>
             </a:r>
+            <a:r>
+              <a:rPr lang="en-US" sz="1950" dirty="0" spc="-4" kern="0">
+                <a:solidFill>
+                  <a:srgbClr val="6B6A66"/>
+                </a:solidFill>
+                <a:latin typeface="Be Vietnam Pro" pitchFamily="34" charset="0"/>
+                <a:ea typeface="Be Vietnam Pro" pitchFamily="34" charset="-122"/>
+                <a:cs typeface="Be Vietnam Pro" pitchFamily="34" charset="-120"/>
+              </a:rPr>
+              <a:t> ·</a:t>
+            </a:r>
+            <a:r>
+              <a:rPr lang="en-US" sz="1950" dirty="0" spc="1" kern="0">
+                <a:solidFill>
+                  <a:srgbClr val="6B6A66"/>
+                </a:solidFill>
+                <a:latin typeface="Be Vietnam Pro" pitchFamily="34" charset="0"/>
+                <a:ea typeface="Be Vietnam Pro" pitchFamily="34" charset="-122"/>
+                <a:cs typeface="Be Vietnam Pro" pitchFamily="34" charset="-120"/>
+              </a:rPr>
+              <a:t> quảng</a:t>
+            </a:r>
+            <a:r>
+              <a:rPr lang="en-US" sz="1950" dirty="0" spc="-1" kern="0">
+                <a:solidFill>
+                  <a:srgbClr val="6B6A66"/>
+                </a:solidFill>
+                <a:latin typeface="Be Vietnam Pro" pitchFamily="34" charset="0"/>
+                <a:ea typeface="Be Vietnam Pro" pitchFamily="34" charset="-122"/>
+                <a:cs typeface="Be Vietnam Pro" pitchFamily="34" charset="-120"/>
+              </a:rPr>
+              <a:t> cáo</a:t>
+            </a:r>
             <a:endParaRPr lang="en-US" sz="1950" dirty="0"/>
           </a:p>
         </p:txBody>
@@ -15579,7 +15722,7 @@
               <a:buNone/>
             </a:pPr>
             <a:r>
-              <a:rPr lang="en-US" sz="2100" dirty="0" spc="-24" kern="0">
+              <a:rPr lang="en-US" sz="2100" dirty="0" spc="-2" kern="0">
                 <a:solidFill>
                   <a:srgbClr val="6B6A66"/>
                 </a:solidFill>
@@ -15587,10 +15730,10 @@
                 <a:ea typeface="Be Vietnam Pro" pitchFamily="34" charset="-122"/>
                 <a:cs typeface="Be Vietnam Pro" pitchFamily="34" charset="-120"/>
               </a:rPr>
-              <a:t>Kênh</a:t>
-            </a:r>
-            <a:r>
-              <a:rPr lang="en-US" sz="2100" dirty="0" spc="12" kern="0">
+              <a:t>Cấp</a:t>
+            </a:r>
+            <a:r>
+              <a:rPr lang="en-US" sz="2100" dirty="0" spc="-7" kern="0">
                 <a:solidFill>
                   <a:srgbClr val="6B6A66"/>
                 </a:solidFill>
@@ -15598,6 +15741,72 @@
                 <a:ea typeface="Be Vietnam Pro" pitchFamily="34" charset="-122"/>
                 <a:cs typeface="Be Vietnam Pro" pitchFamily="34" charset="-120"/>
               </a:rPr>
+              <a:t> sớm</a:t>
+            </a:r>
+            <a:r>
+              <a:rPr lang="en-US" sz="2100" dirty="0" spc="-4" kern="0">
+                <a:solidFill>
+                  <a:srgbClr val="6B6A66"/>
+                </a:solidFill>
+                <a:latin typeface="Be Vietnam Pro" pitchFamily="34" charset="0"/>
+                <a:ea typeface="Be Vietnam Pro" pitchFamily="34" charset="-122"/>
+                <a:cs typeface="Be Vietnam Pro" pitchFamily="34" charset="-120"/>
+              </a:rPr>
+              <a:t> 500</a:t>
+            </a:r>
+            <a:r>
+              <a:rPr lang="en-US" sz="2100" dirty="0" spc="-1" kern="0">
+                <a:solidFill>
+                  <a:srgbClr val="6B6A66"/>
+                </a:solidFill>
+                <a:latin typeface="Be Vietnam Pro" pitchFamily="34" charset="0"/>
+                <a:ea typeface="Be Vietnam Pro" pitchFamily="34" charset="-122"/>
+                <a:cs typeface="Be Vietnam Pro" pitchFamily="34" charset="-120"/>
+              </a:rPr>
+              <a:t> sub không</a:t>
+            </a:r>
+            <a:r>
+              <a:rPr lang="en-US" sz="2100" dirty="0" spc="10" kern="0">
+                <a:solidFill>
+                  <a:srgbClr val="6B6A66"/>
+                </a:solidFill>
+                <a:latin typeface="Be Vietnam Pro" pitchFamily="34" charset="0"/>
+                <a:ea typeface="Be Vietnam Pro" pitchFamily="34" charset="-122"/>
+                <a:cs typeface="Be Vietnam Pro" pitchFamily="34" charset="-120"/>
+              </a:rPr>
+              <a:t> đổi</a:t>
+            </a:r>
+            <a:r>
+              <a:rPr lang="en-US" sz="2100" dirty="0" spc="-4" kern="0">
+                <a:solidFill>
+                  <a:srgbClr val="6B6A66"/>
+                </a:solidFill>
+                <a:latin typeface="Be Vietnam Pro" pitchFamily="34" charset="0"/>
+                <a:ea typeface="Be Vietnam Pro" pitchFamily="34" charset="-122"/>
+                <a:cs typeface="Be Vietnam Pro" pitchFamily="34" charset="-120"/>
+              </a:rPr>
+              <a:t> ·</a:t>
+            </a:r>
+            <a:r>
+              <a:rPr lang="en-US" sz="2100" dirty="0" spc="-18" kern="0">
+                <a:solidFill>
+                  <a:srgbClr val="6B6A66"/>
+                </a:solidFill>
+                <a:latin typeface="Be Vietnam Pro" pitchFamily="34" charset="0"/>
+                <a:ea typeface="Be Vietnam Pro" pitchFamily="34" charset="-122"/>
+                <a:cs typeface="Be Vietnam Pro" pitchFamily="34" charset="-120"/>
+              </a:rPr>
+              <a:t> kênh</a:t>
+            </a:r>
+            <a:r>
+              <a:rPr lang="en-US" sz="2100" dirty="0" spc="13" kern="0">
+                <a:solidFill>
+                  <a:srgbClr val="6B6A66"/>
+                </a:solidFill>
+                <a:latin typeface="Be Vietnam Pro" pitchFamily="34" charset="0"/>
+                <a:ea typeface="Be Vietnam Pro" pitchFamily="34" charset="-122"/>
+                <a:cs typeface="Be Vietnam Pro" pitchFamily="34" charset="-120"/>
+              </a:rPr>
               <a:t> đã</a:t>
             </a:r>
             <a:r>
@@ -15620,10 +15829,10 @@
                 <a:ea typeface="Be Vietnam Pro" pitchFamily="34" charset="-122"/>
                 <a:cs typeface="Be Vietnam Pro" pitchFamily="34" charset="-120"/>
               </a:rPr>
-              <a:t> YPP không bị ảnh</a:t>
-            </a:r>
-            <a:r>
-              <a:rPr lang="en-US" sz="2100" dirty="0" spc="3" kern="0">
+              <a:t> YPP không bị</a:t>
+            </a:r>
+            <a:r>
+              <a:rPr lang="en-US" sz="2100" dirty="0" spc="-2" kern="0">
                 <a:solidFill>
                   <a:srgbClr val="6B6A66"/>
                 </a:solidFill>
@@ -15631,18 +15840,18 @@
                 <a:ea typeface="Be Vietnam Pro" pitchFamily="34" charset="-122"/>
                 <a:cs typeface="Be Vietnam Pro" pitchFamily="34" charset="-120"/>
               </a:rPr>
+              <a:t> ảnh</a:t>
+            </a:r>
+            <a:r>
+              <a:rPr lang="en-US" sz="2100" dirty="0" spc="4" kern="0">
+                <a:solidFill>
+                  <a:srgbClr val="6B6A66"/>
+                </a:solidFill>
+                <a:latin typeface="Be Vietnam Pro" pitchFamily="34" charset="0"/>
+                <a:ea typeface="Be Vietnam Pro" pitchFamily="34" charset="-122"/>
+                <a:cs typeface="Be Vietnam Pro" pitchFamily="34" charset="-120"/>
+              </a:rPr>
               <a:t> hưởng</a:t>
-            </a:r>
-            <a:r>
-              <a:rPr lang="en-US" sz="2100" dirty="0" spc="-2" kern="0">
-                <a:solidFill>
-                  <a:srgbClr val="6B6A66"/>
-                </a:solidFill>
-                <a:latin typeface="Be Vietnam Pro" pitchFamily="34" charset="0"/>
-                <a:ea typeface="Be Vietnam Pro" pitchFamily="34" charset="-122"/>
-                <a:cs typeface="Be Vietnam Pro" pitchFamily="34" charset="-120"/>
-              </a:rPr>
-              <a:t> tư cách</a:t>
             </a:r>
             <a:endParaRPr lang="en-US" sz="2100" dirty="0"/>
           </a:p>

</xml_diff>

<commit_message>
Add the three-uploads prerequisite to the YouTube early monetization tier
The 500-subscriber tier (fan funding, Creator Partnerships, Shopping) also
requires 3 valid public uploads in the last 90 days on both paths, per the
official expanded YPP page. The report (summary item 3, section 3.2 table and
the 2027 list, the summary table, Appendix A, sources) and slide 5 stated only
the subscriber and watch-hour or Shorts-view figures.

Slide 5's Vietnam note moves to the TikTok row so each line fits its box. The
PPTX is re-exported from Moda (12 slides, moda.app badge kept on all).

Co-Authored-By: Claude Sonnet 5.5 <noreply@anthropic.com>
Claude-Session: https://claude.ai/code/session_018uW6gkgn9CUzNGw4ERV2G7
</commit_message>
<xml_diff>
--- a/research/xu-huong-kiem-tien-youtube-tiktok-facebook.pptx
+++ b/research/xu-huong-kiem-tien-youtube-tiktok-facebook.pptx
@@ -15239,7 +15239,7 @@
               <a:t>Cấp</a:t>
             </a:r>
             <a:r>
-              <a:rPr lang="en-US" sz="2100" dirty="0" spc="-7" kern="0">
+              <a:rPr lang="en-US" sz="2100" dirty="0" spc="-5" kern="0">
                 <a:solidFill>
                   <a:srgbClr val="6B6A66"/>
                 </a:solidFill>
@@ -15247,7 +15247,29 @@
                 <a:ea typeface="Be Vietnam Pro" pitchFamily="34" charset="-122"/>
                 <a:cs typeface="Be Vietnam Pro" pitchFamily="34" charset="-120"/>
               </a:rPr>
-              <a:t> sớm</a:t>
+              <a:t> sớm: 500</a:t>
+            </a:r>
+            <a:r>
+              <a:rPr lang="en-US" sz="2100" dirty="0" spc="-1" kern="0">
+                <a:solidFill>
+                  <a:srgbClr val="6B6A66"/>
+                </a:solidFill>
+                <a:latin typeface="Be Vietnam Pro" pitchFamily="34" charset="0"/>
+                <a:ea typeface="Be Vietnam Pro" pitchFamily="34" charset="-122"/>
+                <a:cs typeface="Be Vietnam Pro" pitchFamily="34" charset="-120"/>
+              </a:rPr>
+              <a:t> sub +</a:t>
+            </a:r>
+            <a:r>
+              <a:rPr lang="en-US" sz="2100" dirty="0" spc="-3" kern="0">
+                <a:solidFill>
+                  <a:srgbClr val="6B6A66"/>
+                </a:solidFill>
+                <a:latin typeface="Be Vietnam Pro" pitchFamily="34" charset="0"/>
+                <a:ea typeface="Be Vietnam Pro" pitchFamily="34" charset="-122"/>
+                <a:cs typeface="Be Vietnam Pro" pitchFamily="34" charset="-120"/>
+              </a:rPr>
+              <a:t> 3</a:t>
             </a:r>
             <a:r>
               <a:rPr lang="en-US" sz="2100" dirty="0" spc="-4" kern="0">
@@ -15258,7 +15280,18 @@
                 <a:ea typeface="Be Vietnam Pro" pitchFamily="34" charset="-122"/>
                 <a:cs typeface="Be Vietnam Pro" pitchFamily="34" charset="-120"/>
               </a:rPr>
-              <a:t> 500</a:t>
+              <a:t> video</a:t>
+            </a:r>
+            <a:r>
+              <a:rPr lang="en-US" sz="2100" dirty="0" spc="-2" kern="0">
+                <a:solidFill>
+                  <a:srgbClr val="6B6A66"/>
+                </a:solidFill>
+                <a:latin typeface="Be Vietnam Pro" pitchFamily="34" charset="0"/>
+                <a:ea typeface="Be Vietnam Pro" pitchFamily="34" charset="-122"/>
+                <a:cs typeface="Be Vietnam Pro" pitchFamily="34" charset="-120"/>
+              </a:rPr>
+              <a:t> công</a:t>
             </a:r>
             <a:r>
               <a:rPr lang="en-US" sz="2100" dirty="0" spc="-1" kern="0">
@@ -15269,10 +15302,10 @@
                 <a:ea typeface="Be Vietnam Pro" pitchFamily="34" charset="-122"/>
                 <a:cs typeface="Be Vietnam Pro" pitchFamily="34" charset="-120"/>
               </a:rPr>
-              <a:t> sub</a:t>
-            </a:r>
-            <a:r>
-              <a:rPr lang="en-US" sz="2100" dirty="0" spc="-2" kern="0">
+              <a:t> khai/90</a:t>
+            </a:r>
+            <a:r>
+              <a:rPr lang="en-US" sz="2100" dirty="0" spc="-16" kern="0">
                 <a:solidFill>
                   <a:srgbClr val="6B6A66"/>
                 </a:solidFill>
@@ -15280,6 +15313,17 @@
                 <a:ea typeface="Be Vietnam Pro" pitchFamily="34" charset="-122"/>
                 <a:cs typeface="Be Vietnam Pro" pitchFamily="34" charset="-120"/>
               </a:rPr>
+              <a:t> ngày</a:t>
+            </a:r>
+            <a:r>
+              <a:rPr lang="en-US" sz="2100" dirty="0" spc="0" kern="0">
+                <a:solidFill>
+                  <a:srgbClr val="6B6A66"/>
+                </a:solidFill>
+                <a:latin typeface="Be Vietnam Pro" pitchFamily="34" charset="0"/>
+                <a:ea typeface="Be Vietnam Pro" pitchFamily="34" charset="-122"/>
+                <a:cs typeface="Be Vietnam Pro" pitchFamily="34" charset="-120"/>
+              </a:rPr>
               <a:t> +</a:t>
             </a:r>
             <a:r>
@@ -15313,10 +15357,10 @@
                 <a:ea typeface="Be Vietnam Pro" pitchFamily="34" charset="-122"/>
                 <a:cs typeface="Be Vietnam Pro" pitchFamily="34" charset="-120"/>
               </a:rPr>
-              <a:t> hoặc</a:t>
-            </a:r>
-            <a:r>
-              <a:rPr lang="en-US" sz="2100" dirty="0" spc="-3" kern="0">
+              <a:t> hoặc 3</a:t>
+            </a:r>
+            <a:r>
+              <a:rPr lang="en-US" sz="2100" dirty="0" spc="7" kern="0">
                 <a:solidFill>
                   <a:srgbClr val="6B6A66"/>
                 </a:solidFill>
@@ -15324,10 +15368,10 @@
                 <a:ea typeface="Be Vietnam Pro" pitchFamily="34" charset="-122"/>
                 <a:cs typeface="Be Vietnam Pro" pitchFamily="34" charset="-120"/>
               </a:rPr>
-              <a:t> 3</a:t>
-            </a:r>
-            <a:r>
-              <a:rPr lang="en-US" sz="2100" dirty="0" spc="7" kern="0">
+              <a:t> triệu</a:t>
+            </a:r>
+            <a:r>
+              <a:rPr lang="en-US" sz="2100" dirty="0" spc="-1" kern="0">
                 <a:solidFill>
                   <a:srgbClr val="6B6A66"/>
                 </a:solidFill>
@@ -15335,84 +15379,7 @@
                 <a:ea typeface="Be Vietnam Pro" pitchFamily="34" charset="-122"/>
                 <a:cs typeface="Be Vietnam Pro" pitchFamily="34" charset="-120"/>
               </a:rPr>
-              <a:t> triệu</a:t>
-            </a:r>
-            <a:r>
-              <a:rPr lang="en-US" sz="2100" dirty="0" spc="-1" kern="0">
-                <a:solidFill>
-                  <a:srgbClr val="6B6A66"/>
-                </a:solidFill>
-                <a:latin typeface="Be Vietnam Pro" pitchFamily="34" charset="0"/>
-                <a:ea typeface="Be Vietnam Pro" pitchFamily="34" charset="-122"/>
-                <a:cs typeface="Be Vietnam Pro" pitchFamily="34" charset="-120"/>
-              </a:rPr>
               <a:t> Shorts</a:t>
-            </a:r>
-            <a:r>
-              <a:rPr lang="en-US" sz="2100" dirty="0" spc="-4" kern="0">
-                <a:solidFill>
-                  <a:srgbClr val="6B6A66"/>
-                </a:solidFill>
-                <a:latin typeface="Be Vietnam Pro" pitchFamily="34" charset="0"/>
-                <a:ea typeface="Be Vietnam Pro" pitchFamily="34" charset="-122"/>
-                <a:cs typeface="Be Vietnam Pro" pitchFamily="34" charset="-120"/>
-              </a:rPr>
-              <a:t> ·</a:t>
-            </a:r>
-            <a:r>
-              <a:rPr lang="en-US" sz="2100" dirty="0" spc="-5" kern="0">
-                <a:solidFill>
-                  <a:srgbClr val="6B6A66"/>
-                </a:solidFill>
-                <a:latin typeface="Be Vietnam Pro" pitchFamily="34" charset="0"/>
-                <a:ea typeface="Be Vietnam Pro" pitchFamily="34" charset="-122"/>
-                <a:cs typeface="Be Vietnam Pro" pitchFamily="34" charset="-120"/>
-              </a:rPr>
-              <a:t> Việt</a:t>
-            </a:r>
-            <a:r>
-              <a:rPr lang="en-US" sz="2100" dirty="0" spc="-1" kern="0">
-                <a:solidFill>
-                  <a:srgbClr val="6B6A66"/>
-                </a:solidFill>
-                <a:latin typeface="Be Vietnam Pro" pitchFamily="34" charset="0"/>
-                <a:ea typeface="Be Vietnam Pro" pitchFamily="34" charset="-122"/>
-                <a:cs typeface="Be Vietnam Pro" pitchFamily="34" charset="-120"/>
-              </a:rPr>
-              <a:t> Nam</a:t>
-            </a:r>
-            <a:r>
-              <a:rPr lang="en-US" sz="2100" dirty="0" spc="-4" kern="0">
-                <a:solidFill>
-                  <a:srgbClr val="6B6A66"/>
-                </a:solidFill>
-                <a:latin typeface="Be Vietnam Pro" pitchFamily="34" charset="0"/>
-                <a:ea typeface="Be Vietnam Pro" pitchFamily="34" charset="-122"/>
-                <a:cs typeface="Be Vietnam Pro" pitchFamily="34" charset="-120"/>
-              </a:rPr>
-              <a:t> có</a:t>
-            </a:r>
-            <a:r>
-              <a:rPr lang="en-US" sz="2100" dirty="0" spc="-15" kern="0">
-                <a:solidFill>
-                  <a:srgbClr val="6B6A66"/>
-                </a:solidFill>
-                <a:latin typeface="Be Vietnam Pro" pitchFamily="34" charset="0"/>
-                <a:ea typeface="Be Vietnam Pro" pitchFamily="34" charset="-122"/>
-                <a:cs typeface="Be Vietnam Pro" pitchFamily="34" charset="-120"/>
-              </a:rPr>
-              <a:t> trong</a:t>
-            </a:r>
-            <a:r>
-              <a:rPr lang="en-US" sz="2100" dirty="0" spc="0" kern="0">
-                <a:solidFill>
-                  <a:srgbClr val="6B6A66"/>
-                </a:solidFill>
-                <a:latin typeface="Be Vietnam Pro" pitchFamily="34" charset="0"/>
-                <a:ea typeface="Be Vietnam Pro" pitchFamily="34" charset="-122"/>
-                <a:cs typeface="Be Vietnam Pro" pitchFamily="34" charset="-120"/>
-              </a:rPr>
-              <a:t> YPP</a:t>
             </a:r>
             <a:endParaRPr lang="en-US" sz="2100" dirty="0"/>
           </a:p>
@@ -15744,6 +15711,28 @@
               <a:t> sớm</a:t>
             </a:r>
             <a:r>
+              <a:rPr lang="en-US" sz="2100" dirty="0" spc="-12" kern="0">
+                <a:solidFill>
+                  <a:srgbClr val="6B6A66"/>
+                </a:solidFill>
+                <a:latin typeface="Be Vietnam Pro" pitchFamily="34" charset="0"/>
+                <a:ea typeface="Be Vietnam Pro" pitchFamily="34" charset="-122"/>
+                <a:cs typeface="Be Vietnam Pro" pitchFamily="34" charset="-120"/>
+              </a:rPr>
+              <a:t> vẫn</a:t>
+            </a:r>
+            <a:r>
+              <a:rPr lang="en-US" sz="2100" dirty="0" spc="-2" kern="0">
+                <a:solidFill>
+                  <a:srgbClr val="6B6A66"/>
+                </a:solidFill>
+                <a:latin typeface="Be Vietnam Pro" pitchFamily="34" charset="0"/>
+                <a:ea typeface="Be Vietnam Pro" pitchFamily="34" charset="-122"/>
+                <a:cs typeface="Be Vietnam Pro" pitchFamily="34" charset="-120"/>
+              </a:rPr>
+              <a:t> cần 3</a:t>
+            </a:r>
+            <a:r>
               <a:rPr lang="en-US" sz="2100" dirty="0" spc="-4" kern="0">
                 <a:solidFill>
                   <a:srgbClr val="6B6A66"/>
@@ -15752,7 +15741,18 @@
                 <a:ea typeface="Be Vietnam Pro" pitchFamily="34" charset="-122"/>
                 <a:cs typeface="Be Vietnam Pro" pitchFamily="34" charset="-120"/>
               </a:rPr>
-              <a:t> 500</a:t>
+              <a:t> video</a:t>
+            </a:r>
+            <a:r>
+              <a:rPr lang="en-US" sz="2100" dirty="0" spc="-2" kern="0">
+                <a:solidFill>
+                  <a:srgbClr val="6B6A66"/>
+                </a:solidFill>
+                <a:latin typeface="Be Vietnam Pro" pitchFamily="34" charset="0"/>
+                <a:ea typeface="Be Vietnam Pro" pitchFamily="34" charset="-122"/>
+                <a:cs typeface="Be Vietnam Pro" pitchFamily="34" charset="-120"/>
+              </a:rPr>
+              <a:t> công</a:t>
             </a:r>
             <a:r>
               <a:rPr lang="en-US" sz="2100" dirty="0" spc="-1" kern="0">
@@ -15763,10 +15763,10 @@
                 <a:ea typeface="Be Vietnam Pro" pitchFamily="34" charset="-122"/>
                 <a:cs typeface="Be Vietnam Pro" pitchFamily="34" charset="-120"/>
               </a:rPr>
-              <a:t> sub không</a:t>
-            </a:r>
-            <a:r>
-              <a:rPr lang="en-US" sz="2100" dirty="0" spc="10" kern="0">
+              <a:t> khai/90</a:t>
+            </a:r>
+            <a:r>
+              <a:rPr lang="en-US" sz="2100" dirty="0" spc="-16" kern="0">
                 <a:solidFill>
                   <a:srgbClr val="6B6A66"/>
                 </a:solidFill>
@@ -15774,10 +15774,10 @@
                 <a:ea typeface="Be Vietnam Pro" pitchFamily="34" charset="-122"/>
                 <a:cs typeface="Be Vietnam Pro" pitchFamily="34" charset="-120"/>
               </a:rPr>
-              <a:t> đổi</a:t>
-            </a:r>
-            <a:r>
-              <a:rPr lang="en-US" sz="2100" dirty="0" spc="-4" kern="0">
+              <a:t> ngày</a:t>
+            </a:r>
+            <a:r>
+              <a:rPr lang="en-US" sz="2100" dirty="0" spc="-2" kern="0">
                 <a:solidFill>
                   <a:srgbClr val="6B6A66"/>
                 </a:solidFill>
@@ -15799,7 +15799,7 @@
               <a:t> kênh</a:t>
             </a:r>
             <a:r>
-              <a:rPr lang="en-US" sz="2100" dirty="0" spc="13" kern="0">
+              <a:rPr lang="en-US" sz="2100" dirty="0" spc="12" kern="0">
                 <a:solidFill>
                   <a:srgbClr val="6B6A66"/>
                 </a:solidFill>
@@ -15821,6 +15821,17 @@
               <a:t> vào</a:t>
             </a:r>
             <a:r>
+              <a:rPr lang="en-US" sz="2100" dirty="0" spc="0" kern="0">
+                <a:solidFill>
+                  <a:srgbClr val="6B6A66"/>
+                </a:solidFill>
+                <a:latin typeface="Be Vietnam Pro" pitchFamily="34" charset="0"/>
+                <a:ea typeface="Be Vietnam Pro" pitchFamily="34" charset="-122"/>
+                <a:cs typeface="Be Vietnam Pro" pitchFamily="34" charset="-120"/>
+              </a:rPr>
+              <a:t> YPP</a:t>
+            </a:r>
+            <a:r>
               <a:rPr lang="en-US" sz="2100" dirty="0" spc="-1" kern="0">
                 <a:solidFill>
                   <a:srgbClr val="6B6A66"/>
@@ -15829,7 +15840,7 @@
                 <a:ea typeface="Be Vietnam Pro" pitchFamily="34" charset="-122"/>
                 <a:cs typeface="Be Vietnam Pro" pitchFamily="34" charset="-120"/>
               </a:rPr>
-              <a:t> YPP không bị</a:t>
+              <a:t> không</a:t>
             </a:r>
             <a:r>
               <a:rPr lang="en-US" sz="2100" dirty="0" spc="-2" kern="0">
@@ -15840,10 +15851,21 @@
                 <a:ea typeface="Be Vietnam Pro" pitchFamily="34" charset="-122"/>
                 <a:cs typeface="Be Vietnam Pro" pitchFamily="34" charset="-120"/>
               </a:rPr>
+              <a:t> bị</a:t>
+            </a:r>
+            <a:r>
+              <a:rPr lang="en-US" sz="2100" dirty="0" spc="-1" kern="0">
+                <a:solidFill>
+                  <a:srgbClr val="6B6A66"/>
+                </a:solidFill>
+                <a:latin typeface="Be Vietnam Pro" pitchFamily="34" charset="0"/>
+                <a:ea typeface="Be Vietnam Pro" pitchFamily="34" charset="-122"/>
+                <a:cs typeface="Be Vietnam Pro" pitchFamily="34" charset="-120"/>
+              </a:rPr>
               <a:t> ảnh</a:t>
             </a:r>
             <a:r>
-              <a:rPr lang="en-US" sz="2100" dirty="0" spc="4" kern="0">
+              <a:rPr lang="en-US" sz="2100" dirty="0" spc="3" kern="0">
                 <a:solidFill>
                   <a:srgbClr val="6B6A66"/>
                 </a:solidFill>
@@ -16235,7 +16257,62 @@
                 <a:ea typeface="Be Vietnam Pro" pitchFamily="34" charset="-122"/>
                 <a:cs typeface="Be Vietnam Pro" pitchFamily="34" charset="-120"/>
               </a:rPr>
-              <a:t> Nam</a:t>
+              <a:t> Nam (YPP của</a:t>
+            </a:r>
+            <a:r>
+              <a:rPr lang="en-US" sz="2100" dirty="0" spc="-56" kern="0">
+                <a:solidFill>
+                  <a:srgbClr val="6B6A66"/>
+                </a:solidFill>
+                <a:latin typeface="Be Vietnam Pro" pitchFamily="34" charset="0"/>
+                <a:ea typeface="Be Vietnam Pro" pitchFamily="34" charset="-122"/>
+                <a:cs typeface="Be Vietnam Pro" pitchFamily="34" charset="-120"/>
+              </a:rPr>
+              <a:t> YouTube</a:t>
+            </a:r>
+            <a:r>
+              <a:rPr lang="en-US" sz="2100" dirty="0" spc="-3" kern="0">
+                <a:solidFill>
+                  <a:srgbClr val="6B6A66"/>
+                </a:solidFill>
+                <a:latin typeface="Be Vietnam Pro" pitchFamily="34" charset="0"/>
+                <a:ea typeface="Be Vietnam Pro" pitchFamily="34" charset="-122"/>
+                <a:cs typeface="Be Vietnam Pro" pitchFamily="34" charset="-120"/>
+              </a:rPr>
+              <a:t> có mở</a:t>
+            </a:r>
+            <a:r>
+              <a:rPr lang="en-US" sz="2100" dirty="0" spc="-2" kern="0">
+                <a:solidFill>
+                  <a:srgbClr val="6B6A66"/>
+                </a:solidFill>
+                <a:latin typeface="Be Vietnam Pro" pitchFamily="34" charset="0"/>
+                <a:ea typeface="Be Vietnam Pro" pitchFamily="34" charset="-122"/>
+                <a:cs typeface="Be Vietnam Pro" pitchFamily="34" charset="-120"/>
+              </a:rPr>
+              <a:t> cho</a:t>
+            </a:r>
+            <a:r>
+              <a:rPr lang="en-US" sz="2100" dirty="0" spc="-5" kern="0">
+                <a:solidFill>
+                  <a:srgbClr val="6B6A66"/>
+                </a:solidFill>
+                <a:latin typeface="Be Vietnam Pro" pitchFamily="34" charset="0"/>
+                <a:ea typeface="Be Vietnam Pro" pitchFamily="34" charset="-122"/>
+                <a:cs typeface="Be Vietnam Pro" pitchFamily="34" charset="-120"/>
+              </a:rPr>
+              <a:t> Việt</a:t>
+            </a:r>
+            <a:r>
+              <a:rPr lang="en-US" sz="2100" dirty="0" spc="-2" kern="0">
+                <a:solidFill>
+                  <a:srgbClr val="6B6A66"/>
+                </a:solidFill>
+                <a:latin typeface="Be Vietnam Pro" pitchFamily="34" charset="0"/>
+                <a:ea typeface="Be Vietnam Pro" pitchFamily="34" charset="-122"/>
+                <a:cs typeface="Be Vietnam Pro" pitchFamily="34" charset="-120"/>
+              </a:rPr>
+              <a:t> Nam)</a:t>
             </a:r>
             <a:endParaRPr lang="en-US" sz="2100" dirty="0"/>
           </a:p>

</xml_diff>

<commit_message>
Keep the 1,000-subscriber requirement in the 2027 YPP summaries of the deck and the report
Slide 2 and slide 5 gave the new entry rule as 8,000 watch hours or 20 million
Shorts views and left out the 1,000 subscribers that the official page says
remain required (slide 6 and the report body already had it). Both slides now
say it, the report's summary line says it, and the deck is exported again from
Moda (12 slides, the moda.app badge kept on every slide).

Co-Authored-By: Claude Sonnet 5.5 <noreply@anthropic.com>
Claude-Session: https://claude.ai/code/session_018uW6gkgn9CUzNGw4ERV2G7
</commit_message>
<xml_diff>
--- a/research/xu-huong-kiem-tien-youtube-tiktok-facebook.pptx
+++ b/research/xu-huong-kiem-tien-youtube-tiktok-facebook.pptx
@@ -9257,7 +9257,7 @@
                 <a:ea typeface="Be Vietnam Pro" pitchFamily="34" charset="-122"/>
                 <a:cs typeface="Be Vietnam Pro" pitchFamily="34" charset="-120"/>
               </a:rPr>
-              <a:t> 8.000</a:t>
+              <a:t> 1.000 sub + 8.000</a:t>
             </a:r>
             <a:r>
               <a:rPr lang="en-US" sz="2700" dirty="0" spc="-2" kern="0">
@@ -9271,26 +9271,15 @@
               <a:t> giờ</a:t>
             </a:r>
             <a:r>
-              <a:rPr lang="en-US" sz="2700" dirty="0" spc="-4" kern="0">
-                <a:solidFill>
-                  <a:srgbClr val="14161C"/>
-                </a:solidFill>
-                <a:latin typeface="Be Vietnam Pro" pitchFamily="34" charset="0"/>
-                <a:ea typeface="Be Vietnam Pro" pitchFamily="34" charset="-122"/>
-                <a:cs typeface="Be Vietnam Pro" pitchFamily="34" charset="-120"/>
-              </a:rPr>
-              <a:t> hoặc</a:t>
-            </a:r>
-            <a:r>
-              <a:rPr lang="en-US" sz="2700" dirty="0" spc="-2" kern="0">
-                <a:solidFill>
-                  <a:srgbClr val="14161C"/>
-                </a:solidFill>
-                <a:latin typeface="Be Vietnam Pro" pitchFamily="34" charset="0"/>
-                <a:ea typeface="Be Vietnam Pro" pitchFamily="34" charset="-122"/>
-                <a:cs typeface="Be Vietnam Pro" pitchFamily="34" charset="-120"/>
-              </a:rPr>
-              <a:t> 20</a:t>
+              <a:rPr lang="en-US" sz="2700" dirty="0" spc="-3" kern="0">
+                <a:solidFill>
+                  <a:srgbClr val="14161C"/>
+                </a:solidFill>
+                <a:latin typeface="Be Vietnam Pro" pitchFamily="34" charset="0"/>
+                <a:ea typeface="Be Vietnam Pro" pitchFamily="34" charset="-122"/>
+                <a:cs typeface="Be Vietnam Pro" pitchFamily="34" charset="-120"/>
+              </a:rPr>
+              <a:t> hoặc 20</a:t>
             </a:r>
             <a:r>
               <a:rPr lang="en-US" sz="2700" dirty="0" spc="8" kern="0">
@@ -15562,7 +15551,7 @@
               <a:buNone/>
             </a:pPr>
             <a:r>
-              <a:rPr lang="en-US" sz="2700" b="1" dirty="0" spc="13" kern="0">
+              <a:rPr lang="en-US" sz="2550" b="1" dirty="0" spc="14" kern="0">
                 <a:solidFill>
                   <a:srgbClr val="14161C"/>
                 </a:solidFill>
@@ -15573,7 +15562,7 @@
               <a:t>Người</a:t>
             </a:r>
             <a:r>
-              <a:rPr lang="en-US" sz="2700" b="1" dirty="0" spc="1" kern="0">
+              <a:rPr lang="en-US" sz="2550" b="1" dirty="0" spc="3" kern="0">
                 <a:solidFill>
                   <a:srgbClr val="14161C"/>
                 </a:solidFill>
@@ -15584,18 +15573,29 @@
               <a:t> mới:</a:t>
             </a:r>
             <a:r>
-              <a:rPr lang="en-US" sz="2700" b="1" dirty="0" spc="2" kern="0">
-                <a:solidFill>
-                  <a:srgbClr val="14161C"/>
-                </a:solidFill>
-                <a:latin typeface="Be Vietnam Pro" pitchFamily="34" charset="0"/>
-                <a:ea typeface="Be Vietnam Pro" pitchFamily="34" charset="-122"/>
-                <a:cs typeface="Be Vietnam Pro" pitchFamily="34" charset="-120"/>
-              </a:rPr>
-              <a:t> 8.000</a:t>
-            </a:r>
-            <a:r>
-              <a:rPr lang="en-US" sz="2700" b="1" dirty="0" spc="0" kern="0">
+              <a:rPr lang="en-US" sz="2550" b="1" dirty="0" spc="-1" kern="0">
+                <a:solidFill>
+                  <a:srgbClr val="14161C"/>
+                </a:solidFill>
+                <a:latin typeface="Be Vietnam Pro" pitchFamily="34" charset="0"/>
+                <a:ea typeface="Be Vietnam Pro" pitchFamily="34" charset="-122"/>
+                <a:cs typeface="Be Vietnam Pro" pitchFamily="34" charset="-120"/>
+              </a:rPr>
+              <a:t> 1.000 sub</a:t>
+            </a:r>
+            <a:r>
+              <a:rPr lang="en-US" sz="2550" b="1" dirty="0" spc="0" kern="0">
+                <a:solidFill>
+                  <a:srgbClr val="14161C"/>
+                </a:solidFill>
+                <a:latin typeface="Be Vietnam Pro" pitchFamily="34" charset="0"/>
+                <a:ea typeface="Be Vietnam Pro" pitchFamily="34" charset="-122"/>
+                <a:cs typeface="Be Vietnam Pro" pitchFamily="34" charset="-120"/>
+              </a:rPr>
+              <a:t> + 8.000</a:t>
+            </a:r>
+            <a:r>
+              <a:rPr lang="en-US" sz="2550" b="1" dirty="0" spc="3" kern="0">
                 <a:solidFill>
                   <a:srgbClr val="14161C"/>
                 </a:solidFill>
@@ -15606,7 +15606,7 @@
               <a:t> giờ</a:t>
             </a:r>
             <a:r>
-              <a:rPr lang="en-US" sz="2700" b="1" dirty="0" spc="-2" kern="0">
+              <a:rPr lang="en-US" sz="2550" b="1" dirty="0" spc="-1" kern="0">
                 <a:solidFill>
                   <a:srgbClr val="14161C"/>
                 </a:solidFill>
@@ -15617,7 +15617,7 @@
               <a:t> hoặc</a:t>
             </a:r>
             <a:r>
-              <a:rPr lang="en-US" sz="2700" b="1" dirty="0" spc="1" kern="0">
+              <a:rPr lang="en-US" sz="2550" b="1" dirty="0" spc="1" kern="0">
                 <a:solidFill>
                   <a:srgbClr val="14161C"/>
                 </a:solidFill>
@@ -15628,7 +15628,7 @@
               <a:t> 20</a:t>
             </a:r>
             <a:r>
-              <a:rPr lang="en-US" sz="2700" b="1" dirty="0" spc="5" kern="0">
+              <a:rPr lang="en-US" sz="2550" b="1" dirty="0" spc="6" kern="0">
                 <a:solidFill>
                   <a:srgbClr val="14161C"/>
                 </a:solidFill>
@@ -15639,7 +15639,7 @@
               <a:t> triệu</a:t>
             </a:r>
             <a:r>
-              <a:rPr lang="en-US" sz="2700" b="1" dirty="0" spc="-1" kern="0">
+              <a:rPr lang="en-US" sz="2550" b="1" dirty="0" spc="-1" kern="0">
                 <a:solidFill>
                   <a:srgbClr val="14161C"/>
                 </a:solidFill>
@@ -15650,7 +15650,7 @@
               <a:t> Shorts/90</a:t>
             </a:r>
             <a:r>
-              <a:rPr lang="en-US" sz="2700" b="1" dirty="0" spc="-12" kern="0">
+              <a:rPr lang="en-US" sz="2550" b="1" dirty="0" spc="-11" kern="0">
                 <a:solidFill>
                   <a:srgbClr val="14161C"/>
                 </a:solidFill>
@@ -15660,7 +15660,7 @@
               </a:rPr>
               <a:t> ngày</a:t>
             </a:r>
-            <a:endParaRPr lang="en-US" sz="2700" dirty="0"/>
+            <a:endParaRPr lang="en-US" sz="2550" dirty="0"/>
           </a:p>
         </p:txBody>
       </p:sp>

</xml_diff>

<commit_message>
research: ghi rõ ngưỡng 1 phút của TikTok Creator Rewards
Trang trợ giúp của TikTok ghi video phải dài "ít nhất một phút", còn bài
Creator Academy ghi "hơn 1 phút". Báo cáo và slide 5 bỏ cách viết "trên 1 phút"
chắc nịch, dùng "từ 1 phút", và mục 3.2 nêu rõ hai trang ghi khác nhau kèm
khuyến nghị (suy luận, độ tin cậy thấp) đặt video dài hơn 60 giây một chút.

Co-Authored-By: Claude Sonnet 5.5 <noreply@anthropic.com>
Claude-Session: https://claude.ai/code/session_018uW6gkgn9CUzNGw4ERV2G7
</commit_message>
<xml_diff>
--- a/research/xu-huong-kiem-tien-youtube-tiktok-facebook.pptx
+++ b/research/xu-huong-kiem-tien-youtube-tiktok-facebook.pptx
@@ -16100,15 +16100,15 @@
               <a:t> video</a:t>
             </a:r>
             <a:r>
-              <a:rPr lang="en-US" sz="2700" b="1" dirty="0" spc="-17" kern="0">
-                <a:solidFill>
-                  <a:srgbClr val="14161C"/>
-                </a:solidFill>
-                <a:latin typeface="Be Vietnam Pro" pitchFamily="34" charset="0"/>
-                <a:ea typeface="Be Vietnam Pro" pitchFamily="34" charset="-122"/>
-                <a:cs typeface="Be Vietnam Pro" pitchFamily="34" charset="-120"/>
-              </a:rPr>
-              <a:t> trên</a:t>
+              <a:rPr lang="en-US" sz="2700" b="1" dirty="0" spc="-5" kern="0">
+                <a:solidFill>
+                  <a:srgbClr val="14161C"/>
+                </a:solidFill>
+                <a:latin typeface="Be Vietnam Pro" pitchFamily="34" charset="0"/>
+                <a:ea typeface="Be Vietnam Pro" pitchFamily="34" charset="-122"/>
+                <a:cs typeface="Be Vietnam Pro" pitchFamily="34" charset="-120"/>
+              </a:rPr>
+              <a:t> từ</a:t>
             </a:r>
             <a:r>
               <a:rPr lang="en-US" sz="2700" b="1" dirty="0" spc="-1" kern="0">

</xml_diff>